<commit_message>
Finalize public GitHub-linked submission
</commit_message>
<xml_diff>
--- a/submission/TranTienThinh_final.pptx
+++ b/submission/TranTienThinh_final.pptx
@@ -2,23 +2,23 @@
 <file path=ppt/presentation.xml><?xml version="1.0" encoding="utf-8"?>
 <p:presentation xmlns:p="http://schemas.openxmlformats.org/presentationml/2006/main">
   <p:sldMasterIdLst>
-    <p:sldMasterId xmlns:r="http://schemas.openxmlformats.org/officeDocument/2006/relationships" id="2147483648" r:id="Rec281e5fc94d4e37"/>
+    <p:sldMasterId xmlns:r="http://schemas.openxmlformats.org/officeDocument/2006/relationships" id="2147483648" r:id="R9995026168404779"/>
   </p:sldMasterIdLst>
   <p:notesMasterIdLst>
-    <p:notesMasterId xmlns:r="http://schemas.openxmlformats.org/officeDocument/2006/relationships" r:id="Rc2d5c6eec8b94907"/>
+    <p:notesMasterId xmlns:r="http://schemas.openxmlformats.org/officeDocument/2006/relationships" r:id="R3cab22076bf04409"/>
   </p:notesMasterIdLst>
   <p:sldIdLst>
-    <p:sldId xmlns:r="http://schemas.openxmlformats.org/officeDocument/2006/relationships" id="256" r:id="Rb76e2d1b062342ec"/>
-    <p:sldId xmlns:r="http://schemas.openxmlformats.org/officeDocument/2006/relationships" id="257" r:id="R2a0d5ed315684ebf"/>
-    <p:sldId xmlns:r="http://schemas.openxmlformats.org/officeDocument/2006/relationships" id="258" r:id="R5fefd8c9edf74277"/>
-    <p:sldId xmlns:r="http://schemas.openxmlformats.org/officeDocument/2006/relationships" id="259" r:id="Racc59e029c28464b"/>
-    <p:sldId xmlns:r="http://schemas.openxmlformats.org/officeDocument/2006/relationships" id="260" r:id="Rbc18fe3a981c4a67"/>
-    <p:sldId xmlns:r="http://schemas.openxmlformats.org/officeDocument/2006/relationships" id="261" r:id="Re707ac783e7e48ac"/>
-    <p:sldId xmlns:r="http://schemas.openxmlformats.org/officeDocument/2006/relationships" id="262" r:id="R079b37794fc24bfa"/>
-    <p:sldId xmlns:r="http://schemas.openxmlformats.org/officeDocument/2006/relationships" id="263" r:id="Rc9d1a9b6309f4bf3"/>
-    <p:sldId xmlns:r="http://schemas.openxmlformats.org/officeDocument/2006/relationships" id="264" r:id="Rec6c4c59a43d4ada"/>
-    <p:sldId xmlns:r="http://schemas.openxmlformats.org/officeDocument/2006/relationships" id="265" r:id="R2e0151e0de7141ab"/>
-    <p:sldId xmlns:r="http://schemas.openxmlformats.org/officeDocument/2006/relationships" id="266" r:id="R21e02e2614ff4bd5"/>
+    <p:sldId xmlns:r="http://schemas.openxmlformats.org/officeDocument/2006/relationships" id="256" r:id="Rae1eb953b7d34971"/>
+    <p:sldId xmlns:r="http://schemas.openxmlformats.org/officeDocument/2006/relationships" id="257" r:id="Rc67560e11bb24b17"/>
+    <p:sldId xmlns:r="http://schemas.openxmlformats.org/officeDocument/2006/relationships" id="258" r:id="R5b80e393f15542a4"/>
+    <p:sldId xmlns:r="http://schemas.openxmlformats.org/officeDocument/2006/relationships" id="259" r:id="Rc010486712ff4f10"/>
+    <p:sldId xmlns:r="http://schemas.openxmlformats.org/officeDocument/2006/relationships" id="260" r:id="R501c28d2389a42b2"/>
+    <p:sldId xmlns:r="http://schemas.openxmlformats.org/officeDocument/2006/relationships" id="261" r:id="R7b23397a65124a05"/>
+    <p:sldId xmlns:r="http://schemas.openxmlformats.org/officeDocument/2006/relationships" id="262" r:id="R9b31210cc9824bb2"/>
+    <p:sldId xmlns:r="http://schemas.openxmlformats.org/officeDocument/2006/relationships" id="263" r:id="R99f28245ad3e4bc1"/>
+    <p:sldId xmlns:r="http://schemas.openxmlformats.org/officeDocument/2006/relationships" id="264" r:id="R3323254c909f43d5"/>
+    <p:sldId xmlns:r="http://schemas.openxmlformats.org/officeDocument/2006/relationships" id="265" r:id="Rd7bf4bedcf164835"/>
+    <p:sldId xmlns:r="http://schemas.openxmlformats.org/officeDocument/2006/relationships" id="266" r:id="R6dfd1142a8054d4b"/>
   </p:sldIdLst>
   <p:sldSz cx="12192000" cy="6858000"/>
   <p:notesSz cx="6858000" cy="9144000"/>
@@ -592,7 +592,7 @@
           <a:lstStyle xmlns:a="http://schemas.openxmlformats.org/drawingml/2006/main"/>
           <a:p xmlns:a="http://schemas.openxmlformats.org/drawingml/2006/main">
             <a:r>
-              <a:t>Kết luận ngắn gọn: mục tiêu tương đối đạt, mục tiêu tuyệt đối chưa đạt. Giá trị chính là pipeline minh bạch và tái lập. Nêu hướng tiếp theo. Trước khi nộp phải thay trường GitHub bằng URL thật; không tự nộp LMS. Nguồn: toàn bộ artifact protocol v2 trong dự án.</a:t>
+              <a:t>Kết luận ngắn gọn: mục tiêu tương đối đạt, mục tiêu tuyệt đối chưa đạt. Giá trị chính là pipeline minh bạch và tái lập. Nêu hướng tiếp theo và repository public đã xác minh. Không tự nộp LMS. Nguồn: toàn bộ artifact protocol v2 trong dự án.</a:t>
             </a:r>
           </a:p>
         </p:txBody>
@@ -1220,7 +1220,7 @@
   </p:cSld>
   <p:clrMap bg1="lt1" tx1="dk1" bg2="lt2" tx2="dk2" accent1="accent1" accent2="accent2" accent3="accent3" accent4="accent4" accent5="accent5" accent6="accent6" hlink="hlink" folHlink="folHlink"/>
   <p:sldLayoutIdLst>
-    <p:sldLayoutId xmlns:r="http://schemas.openxmlformats.org/officeDocument/2006/relationships" id="2147483649" r:id="R4c1e2b5db3e54807"/>
+    <p:sldLayoutId xmlns:r="http://schemas.openxmlformats.org/officeDocument/2006/relationships" id="2147483649" r:id="R52f296b90dec4f94"/>
   </p:sldLayoutIdLst>
   <p:txStyles>
     <p:titleStyle>
@@ -2445,7 +2445,7 @@
           <p:cNvPr id="11" name="">
             <a:extLst xmlns:a="http://schemas.openxmlformats.org/drawingml/2006/main">
               <a:ext uri="{FF2B5EF4-FFF2-40B4-BE49-F238E27FC236}">
-                <a16:creationId xmlns:a16="http://schemas.microsoft.com/office/drawing/2014/main" id="{81656293-A36D-4B2D-BBB0-E6E5E4E73DE5}"/>
+                <a16:creationId xmlns:a16="http://schemas.microsoft.com/office/drawing/2014/main" id="{0E3E5098-B359-4F0F-9671-18572492B7DA}"/>
               </a:ext>
             </a:extLst>
           </p:cNvPr>
@@ -2479,7 +2479,7 @@
           <p:nvPr/>
         </p:nvPicPr>
         <p:blipFill>
-          <a:blip xmlns:r="http://schemas.openxmlformats.org/officeDocument/2006/relationships" xmlns:a="http://schemas.openxmlformats.org/drawingml/2006/main" r:embed="R8bc807760da54b9f"/>
+          <a:blip xmlns:r="http://schemas.openxmlformats.org/officeDocument/2006/relationships" xmlns:a="http://schemas.openxmlformats.org/drawingml/2006/main" r:embed="R5b9b69101fdd44a3"/>
           <a:stretch xmlns:a="http://schemas.openxmlformats.org/drawingml/2006/main"/>
         </p:blipFill>
         <p:spPr>
@@ -2497,7 +2497,7 @@
           <p:cNvPr id="3" name="">
             <a:extLst xmlns:a="http://schemas.openxmlformats.org/drawingml/2006/main">
               <a:ext uri="{FF2B5EF4-FFF2-40B4-BE49-F238E27FC236}">
-                <a16:creationId xmlns:a16="http://schemas.microsoft.com/office/drawing/2014/main" id="{0ECC087F-C309-485E-8287-7B8E909B1997}"/>
+                <a16:creationId xmlns:a16="http://schemas.microsoft.com/office/drawing/2014/main" id="{7C0BAAFD-3F0B-40CD-B1D7-194CF932394D}"/>
               </a:ext>
             </a:extLst>
           </p:cNvPr>
@@ -2554,7 +2554,7 @@
           <p:cNvPr id="4" name="">
             <a:extLst xmlns:a="http://schemas.openxmlformats.org/drawingml/2006/main">
               <a:ext uri="{FF2B5EF4-FFF2-40B4-BE49-F238E27FC236}">
-                <a16:creationId xmlns:a16="http://schemas.microsoft.com/office/drawing/2014/main" id="{00F633A4-5FB1-431E-B165-691F86B845B3}"/>
+                <a16:creationId xmlns:a16="http://schemas.microsoft.com/office/drawing/2014/main" id="{99B6C2E6-E3FD-4BCA-B6C0-AD1E13C390A8}"/>
               </a:ext>
             </a:extLst>
           </p:cNvPr>
@@ -2634,7 +2634,7 @@
           <p:cNvPr id="5" name="">
             <a:extLst xmlns:a="http://schemas.openxmlformats.org/drawingml/2006/main">
               <a:ext uri="{FF2B5EF4-FFF2-40B4-BE49-F238E27FC236}">
-                <a16:creationId xmlns:a16="http://schemas.microsoft.com/office/drawing/2014/main" id="{40C48B39-D269-4474-8625-12CD23D1DCBE}"/>
+                <a16:creationId xmlns:a16="http://schemas.microsoft.com/office/drawing/2014/main" id="{244A62B1-F63A-4ED3-8772-B84CAD0A8ADD}"/>
               </a:ext>
             </a:extLst>
           </p:cNvPr>
@@ -2691,7 +2691,7 @@
           <p:cNvPr id="6" name="">
             <a:extLst xmlns:a="http://schemas.openxmlformats.org/drawingml/2006/main">
               <a:ext uri="{FF2B5EF4-FFF2-40B4-BE49-F238E27FC236}">
-                <a16:creationId xmlns:a16="http://schemas.microsoft.com/office/drawing/2014/main" id="{DBE57038-6420-42B1-B274-F34C0057AF45}"/>
+                <a16:creationId xmlns:a16="http://schemas.microsoft.com/office/drawing/2014/main" id="{7619B7CF-F4FB-48A9-A247-4FC5A29D030A}"/>
               </a:ext>
             </a:extLst>
           </p:cNvPr>
@@ -2721,7 +2721,7 @@
           <p:cNvPr id="7" name="">
             <a:extLst xmlns:a="http://schemas.openxmlformats.org/drawingml/2006/main">
               <a:ext uri="{FF2B5EF4-FFF2-40B4-BE49-F238E27FC236}">
-                <a16:creationId xmlns:a16="http://schemas.microsoft.com/office/drawing/2014/main" id="{20EE0D2D-1FC1-4E38-8B76-A9A4204981AD}"/>
+                <a16:creationId xmlns:a16="http://schemas.microsoft.com/office/drawing/2014/main" id="{A8DFE085-8D9B-45F5-8DD8-8BFBB15E00D4}"/>
               </a:ext>
             </a:extLst>
           </p:cNvPr>
@@ -2778,7 +2778,7 @@
           <p:cNvPr id="8" name="">
             <a:extLst xmlns:a="http://schemas.openxmlformats.org/drawingml/2006/main">
               <a:ext uri="{FF2B5EF4-FFF2-40B4-BE49-F238E27FC236}">
-                <a16:creationId xmlns:a16="http://schemas.microsoft.com/office/drawing/2014/main" id="{E2E3928A-A052-40B7-AD54-6542847AE32F}"/>
+                <a16:creationId xmlns:a16="http://schemas.microsoft.com/office/drawing/2014/main" id="{E8DC97EE-5A10-4671-9DBE-7531CB815677}"/>
               </a:ext>
             </a:extLst>
           </p:cNvPr>
@@ -2835,7 +2835,7 @@
           <p:cNvPr id="9" name="">
             <a:extLst xmlns:a="http://schemas.openxmlformats.org/drawingml/2006/main">
               <a:ext uri="{FF2B5EF4-FFF2-40B4-BE49-F238E27FC236}">
-                <a16:creationId xmlns:a16="http://schemas.microsoft.com/office/drawing/2014/main" id="{ECCBDB55-CA54-45E3-8723-0B22B1C50EF4}"/>
+                <a16:creationId xmlns:a16="http://schemas.microsoft.com/office/drawing/2014/main" id="{4F14284E-32C4-45B3-867B-F039F9B75EC5}"/>
               </a:ext>
             </a:extLst>
           </p:cNvPr>
@@ -2915,7 +2915,7 @@
           <p:cNvPr id="10" name="">
             <a:extLst xmlns:a="http://schemas.openxmlformats.org/drawingml/2006/main">
               <a:ext uri="{FF2B5EF4-FFF2-40B4-BE49-F238E27FC236}">
-                <a16:creationId xmlns:a16="http://schemas.microsoft.com/office/drawing/2014/main" id="{4F0D5795-58B9-40FD-89EF-8B267FB632E9}"/>
+                <a16:creationId xmlns:a16="http://schemas.microsoft.com/office/drawing/2014/main" id="{53543C96-F89A-49E0-A481-7C14457AE52E}"/>
               </a:ext>
             </a:extLst>
           </p:cNvPr>
@@ -2970,7 +2970,7 @@
     </p:spTree>
     <p:extLst>
       <p:ext uri="{BB962C8B-B14F-4D97-AF65-F5344CB8AC3E}">
-        <p14:creationId xmlns:p14="http://schemas.microsoft.com/office/powerpoint/2010/main" val="1000104948"/>
+        <p14:creationId xmlns:p14="http://schemas.microsoft.com/office/powerpoint/2010/main" val="649419275"/>
       </p:ext>
     </p:extLst>
   </p:cSld>
@@ -3001,7 +3001,7 @@
           <p:cNvPr id="15" name="">
             <a:extLst xmlns:a="http://schemas.openxmlformats.org/drawingml/2006/main">
               <a:ext uri="{FF2B5EF4-FFF2-40B4-BE49-F238E27FC236}">
-                <a16:creationId xmlns:a16="http://schemas.microsoft.com/office/drawing/2014/main" id="{BC8E9A01-2C3A-43BB-BB9C-2EBBA3DB919A}"/>
+                <a16:creationId xmlns:a16="http://schemas.microsoft.com/office/drawing/2014/main" id="{48547FDA-03D3-4FFE-A6BD-09A0C7FF2473}"/>
               </a:ext>
             </a:extLst>
           </p:cNvPr>
@@ -3058,7 +3058,7 @@
           <p:cNvPr id="2" name="">
             <a:extLst xmlns:a="http://schemas.openxmlformats.org/drawingml/2006/main">
               <a:ext uri="{FF2B5EF4-FFF2-40B4-BE49-F238E27FC236}">
-                <a16:creationId xmlns:a16="http://schemas.microsoft.com/office/drawing/2014/main" id="{9308F803-67D1-463F-AC7A-79AA1BFA6FA3}"/>
+                <a16:creationId xmlns:a16="http://schemas.microsoft.com/office/drawing/2014/main" id="{01B73454-A44C-4AE0-8CCD-804F6A677F2B}"/>
               </a:ext>
             </a:extLst>
           </p:cNvPr>
@@ -3088,7 +3088,7 @@
           <p:cNvPr id="3" name="">
             <a:extLst xmlns:a="http://schemas.openxmlformats.org/drawingml/2006/main">
               <a:ext uri="{FF2B5EF4-FFF2-40B4-BE49-F238E27FC236}">
-                <a16:creationId xmlns:a16="http://schemas.microsoft.com/office/drawing/2014/main" id="{0AC8EE1F-0C95-407B-96EF-DA14EFB8A38D}"/>
+                <a16:creationId xmlns:a16="http://schemas.microsoft.com/office/drawing/2014/main" id="{420FA6BA-E4F9-4CD7-B428-2F84EF57EF3A}"/>
               </a:ext>
             </a:extLst>
           </p:cNvPr>
@@ -3152,7 +3152,7 @@
         </p:xfrm>
         <a:graphic xmlns:a="http://schemas.openxmlformats.org/drawingml/2006/main">
           <a:graphicData uri="http://schemas.openxmlformats.org/drawingml/2006/chart">
-            <c:chart xmlns:r="http://schemas.openxmlformats.org/officeDocument/2006/relationships" xmlns:c="http://schemas.openxmlformats.org/drawingml/2006/chart" r:id="R5b0797a6d59541cc"/>
+            <c:chart xmlns:r="http://schemas.openxmlformats.org/officeDocument/2006/relationships" xmlns:c="http://schemas.openxmlformats.org/drawingml/2006/chart" r:id="Rf21446ec323b4ad1"/>
           </a:graphicData>
         </a:graphic>
       </p:graphicFrame>
@@ -3161,7 +3161,7 @@
           <p:cNvPr id="5" name="">
             <a:extLst xmlns:a="http://schemas.openxmlformats.org/drawingml/2006/main">
               <a:ext uri="{FF2B5EF4-FFF2-40B4-BE49-F238E27FC236}">
-                <a16:creationId xmlns:a16="http://schemas.microsoft.com/office/drawing/2014/main" id="{CCD38610-279D-4D6E-B9E8-D8D3F019A65C}"/>
+                <a16:creationId xmlns:a16="http://schemas.microsoft.com/office/drawing/2014/main" id="{2439FA72-04A5-4E83-87FE-E56064A58B91}"/>
               </a:ext>
             </a:extLst>
           </p:cNvPr>
@@ -3218,7 +3218,7 @@
           <p:cNvPr id="6" name="">
             <a:extLst xmlns:a="http://schemas.openxmlformats.org/drawingml/2006/main">
               <a:ext uri="{FF2B5EF4-FFF2-40B4-BE49-F238E27FC236}">
-                <a16:creationId xmlns:a16="http://schemas.microsoft.com/office/drawing/2014/main" id="{040187BF-3C56-42A7-8F8A-5B19ED65F582}"/>
+                <a16:creationId xmlns:a16="http://schemas.microsoft.com/office/drawing/2014/main" id="{1CC0E1C7-C76F-4D84-8A91-FAD0093B127F}"/>
               </a:ext>
             </a:extLst>
           </p:cNvPr>
@@ -3275,7 +3275,7 @@
           <p:cNvPr id="7" name="">
             <a:extLst xmlns:a="http://schemas.openxmlformats.org/drawingml/2006/main">
               <a:ext uri="{FF2B5EF4-FFF2-40B4-BE49-F238E27FC236}">
-                <a16:creationId xmlns:a16="http://schemas.microsoft.com/office/drawing/2014/main" id="{165A9CBA-0470-4F43-8D56-A2925D329CBE}"/>
+                <a16:creationId xmlns:a16="http://schemas.microsoft.com/office/drawing/2014/main" id="{21507EE9-DBA8-4A45-A699-E20521D856E0}"/>
               </a:ext>
             </a:extLst>
           </p:cNvPr>
@@ -3332,7 +3332,7 @@
           <p:cNvPr id="8" name="">
             <a:extLst xmlns:a="http://schemas.openxmlformats.org/drawingml/2006/main">
               <a:ext uri="{FF2B5EF4-FFF2-40B4-BE49-F238E27FC236}">
-                <a16:creationId xmlns:a16="http://schemas.microsoft.com/office/drawing/2014/main" id="{CD82C3AD-EBEA-4B8F-8174-C55E17345493}"/>
+                <a16:creationId xmlns:a16="http://schemas.microsoft.com/office/drawing/2014/main" id="{6EE92C6D-6F85-4BEC-A5D6-48F78C3DA300}"/>
               </a:ext>
             </a:extLst>
           </p:cNvPr>
@@ -3389,7 +3389,7 @@
           <p:cNvPr id="9" name="">
             <a:extLst xmlns:a="http://schemas.openxmlformats.org/drawingml/2006/main">
               <a:ext uri="{FF2B5EF4-FFF2-40B4-BE49-F238E27FC236}">
-                <a16:creationId xmlns:a16="http://schemas.microsoft.com/office/drawing/2014/main" id="{4BECB49E-497B-431E-A4C3-D05AD205011C}"/>
+                <a16:creationId xmlns:a16="http://schemas.microsoft.com/office/drawing/2014/main" id="{CB1A969E-9131-49AB-95BF-7F10DD8B5396}"/>
               </a:ext>
             </a:extLst>
           </p:cNvPr>
@@ -3446,7 +3446,7 @@
           <p:cNvPr id="10" name="">
             <a:extLst xmlns:a="http://schemas.openxmlformats.org/drawingml/2006/main">
               <a:ext uri="{FF2B5EF4-FFF2-40B4-BE49-F238E27FC236}">
-                <a16:creationId xmlns:a16="http://schemas.microsoft.com/office/drawing/2014/main" id="{91300709-1D62-4D34-89C6-3983EFCAA376}"/>
+                <a16:creationId xmlns:a16="http://schemas.microsoft.com/office/drawing/2014/main" id="{BEDF6636-BB10-4514-92C0-F7E3DF447F6F}"/>
               </a:ext>
             </a:extLst>
           </p:cNvPr>
@@ -3505,7 +3505,7 @@
           <p:cNvPr id="11" name="">
             <a:extLst xmlns:a="http://schemas.openxmlformats.org/drawingml/2006/main">
               <a:ext uri="{FF2B5EF4-FFF2-40B4-BE49-F238E27FC236}">
-                <a16:creationId xmlns:a16="http://schemas.microsoft.com/office/drawing/2014/main" id="{0CCA8EF1-84D2-42BE-AAD0-973475C21D2E}"/>
+                <a16:creationId xmlns:a16="http://schemas.microsoft.com/office/drawing/2014/main" id="{2C383283-47ED-4850-BD35-7811724DCC76}"/>
               </a:ext>
             </a:extLst>
           </p:cNvPr>
@@ -3564,7 +3564,7 @@
           <p:cNvPr id="12" name="">
             <a:extLst xmlns:a="http://schemas.openxmlformats.org/drawingml/2006/main">
               <a:ext uri="{FF2B5EF4-FFF2-40B4-BE49-F238E27FC236}">
-                <a16:creationId xmlns:a16="http://schemas.microsoft.com/office/drawing/2014/main" id="{DA3489DF-0880-4130-8532-0F168392F2BB}"/>
+                <a16:creationId xmlns:a16="http://schemas.microsoft.com/office/drawing/2014/main" id="{1F21A8D1-E1E8-4979-80B0-62C7E2803C02}"/>
               </a:ext>
             </a:extLst>
           </p:cNvPr>
@@ -3594,7 +3594,7 @@
           <p:cNvPr id="13" name="">
             <a:extLst xmlns:a="http://schemas.openxmlformats.org/drawingml/2006/main">
               <a:ext uri="{FF2B5EF4-FFF2-40B4-BE49-F238E27FC236}">
-                <a16:creationId xmlns:a16="http://schemas.microsoft.com/office/drawing/2014/main" id="{A31420B3-4F94-49FD-96E4-725C8512DC0C}"/>
+                <a16:creationId xmlns:a16="http://schemas.microsoft.com/office/drawing/2014/main" id="{277B7E28-932E-4534-B2C3-4F603024A416}"/>
               </a:ext>
             </a:extLst>
           </p:cNvPr>
@@ -3651,7 +3651,7 @@
           <p:cNvPr id="14" name="">
             <a:extLst xmlns:a="http://schemas.openxmlformats.org/drawingml/2006/main">
               <a:ext uri="{FF2B5EF4-FFF2-40B4-BE49-F238E27FC236}">
-                <a16:creationId xmlns:a16="http://schemas.microsoft.com/office/drawing/2014/main" id="{ED456E93-5C30-45E3-9267-A700CF05774A}"/>
+                <a16:creationId xmlns:a16="http://schemas.microsoft.com/office/drawing/2014/main" id="{C64F8C73-B8E0-4765-9706-EB9E49769FC1}"/>
               </a:ext>
             </a:extLst>
           </p:cNvPr>
@@ -3706,7 +3706,7 @@
     </p:spTree>
     <p:extLst>
       <p:ext uri="{BB962C8B-B14F-4D97-AF65-F5344CB8AC3E}">
-        <p14:creationId xmlns:p14="http://schemas.microsoft.com/office/powerpoint/2010/main" val="1289451598"/>
+        <p14:creationId xmlns:p14="http://schemas.microsoft.com/office/powerpoint/2010/main" val="468323048"/>
       </p:ext>
     </p:extLst>
   </p:cSld>
@@ -3737,7 +3737,7 @@
           <p:cNvPr id="20" name="">
             <a:extLst xmlns:a="http://schemas.openxmlformats.org/drawingml/2006/main">
               <a:ext uri="{FF2B5EF4-FFF2-40B4-BE49-F238E27FC236}">
-                <a16:creationId xmlns:a16="http://schemas.microsoft.com/office/drawing/2014/main" id="{D3A616E6-2E44-4A22-A1C9-A265DEC262AE}"/>
+                <a16:creationId xmlns:a16="http://schemas.microsoft.com/office/drawing/2014/main" id="{67F9D693-8140-45E3-88FA-87DAFF7E32C1}"/>
               </a:ext>
             </a:extLst>
           </p:cNvPr>
@@ -3794,7 +3794,7 @@
           <p:cNvPr id="2" name="">
             <a:extLst xmlns:a="http://schemas.openxmlformats.org/drawingml/2006/main">
               <a:ext uri="{FF2B5EF4-FFF2-40B4-BE49-F238E27FC236}">
-                <a16:creationId xmlns:a16="http://schemas.microsoft.com/office/drawing/2014/main" id="{3AD30DB7-0163-4AD8-B708-BC786E445516}"/>
+                <a16:creationId xmlns:a16="http://schemas.microsoft.com/office/drawing/2014/main" id="{2A8F17BD-4435-467C-A378-ED4EFD55F3DE}"/>
               </a:ext>
             </a:extLst>
           </p:cNvPr>
@@ -3824,7 +3824,7 @@
           <p:cNvPr id="3" name="">
             <a:extLst xmlns:a="http://schemas.openxmlformats.org/drawingml/2006/main">
               <a:ext uri="{FF2B5EF4-FFF2-40B4-BE49-F238E27FC236}">
-                <a16:creationId xmlns:a16="http://schemas.microsoft.com/office/drawing/2014/main" id="{DED09575-67C0-463F-AC65-B81E5A60BF05}"/>
+                <a16:creationId xmlns:a16="http://schemas.microsoft.com/office/drawing/2014/main" id="{5FFD2875-AA7F-4B12-BF25-329750E98981}"/>
               </a:ext>
             </a:extLst>
           </p:cNvPr>
@@ -3881,7 +3881,7 @@
           <p:cNvPr id="4" name="">
             <a:extLst xmlns:a="http://schemas.openxmlformats.org/drawingml/2006/main">
               <a:ext uri="{FF2B5EF4-FFF2-40B4-BE49-F238E27FC236}">
-                <a16:creationId xmlns:a16="http://schemas.microsoft.com/office/drawing/2014/main" id="{7CFBCAC7-37D6-4D31-81DD-8492747DF21C}"/>
+                <a16:creationId xmlns:a16="http://schemas.microsoft.com/office/drawing/2014/main" id="{77242593-B303-49C7-8F1A-E9C2138174BA}"/>
               </a:ext>
             </a:extLst>
           </p:cNvPr>
@@ -3938,7 +3938,7 @@
           <p:cNvPr id="5" name="">
             <a:extLst xmlns:a="http://schemas.openxmlformats.org/drawingml/2006/main">
               <a:ext uri="{FF2B5EF4-FFF2-40B4-BE49-F238E27FC236}">
-                <a16:creationId xmlns:a16="http://schemas.microsoft.com/office/drawing/2014/main" id="{5287423B-B753-4732-9944-53BE86DA3A86}"/>
+                <a16:creationId xmlns:a16="http://schemas.microsoft.com/office/drawing/2014/main" id="{C9322E0F-1539-4BBC-B3A3-8A4E50B10260}"/>
               </a:ext>
             </a:extLst>
           </p:cNvPr>
@@ -3995,7 +3995,7 @@
           <p:cNvPr id="6" name="">
             <a:extLst xmlns:a="http://schemas.openxmlformats.org/drawingml/2006/main">
               <a:ext uri="{FF2B5EF4-FFF2-40B4-BE49-F238E27FC236}">
-                <a16:creationId xmlns:a16="http://schemas.microsoft.com/office/drawing/2014/main" id="{B2B8DC7C-76EB-4C9C-98F6-F5DC136409F2}"/>
+                <a16:creationId xmlns:a16="http://schemas.microsoft.com/office/drawing/2014/main" id="{8A19336C-B279-40E2-B781-0BF64CF39EB9}"/>
               </a:ext>
             </a:extLst>
           </p:cNvPr>
@@ -4052,7 +4052,7 @@
           <p:cNvPr id="7" name="">
             <a:extLst xmlns:a="http://schemas.openxmlformats.org/drawingml/2006/main">
               <a:ext uri="{FF2B5EF4-FFF2-40B4-BE49-F238E27FC236}">
-                <a16:creationId xmlns:a16="http://schemas.microsoft.com/office/drawing/2014/main" id="{CD622439-1FC4-4D3B-974C-470C5CC0F1A0}"/>
+                <a16:creationId xmlns:a16="http://schemas.microsoft.com/office/drawing/2014/main" id="{7836179B-DE13-499B-8EAD-730AEFBB925B}"/>
               </a:ext>
             </a:extLst>
           </p:cNvPr>
@@ -4109,7 +4109,7 @@
           <p:cNvPr id="8" name="">
             <a:extLst xmlns:a="http://schemas.openxmlformats.org/drawingml/2006/main">
               <a:ext uri="{FF2B5EF4-FFF2-40B4-BE49-F238E27FC236}">
-                <a16:creationId xmlns:a16="http://schemas.microsoft.com/office/drawing/2014/main" id="{7DB5FFA1-2201-4342-9200-38DFE02A0A1A}"/>
+                <a16:creationId xmlns:a16="http://schemas.microsoft.com/office/drawing/2014/main" id="{563DCF46-7ACD-4978-940D-52689FE57134}"/>
               </a:ext>
             </a:extLst>
           </p:cNvPr>
@@ -4166,7 +4166,7 @@
           <p:cNvPr id="9" name="">
             <a:extLst xmlns:a="http://schemas.openxmlformats.org/drawingml/2006/main">
               <a:ext uri="{FF2B5EF4-FFF2-40B4-BE49-F238E27FC236}">
-                <a16:creationId xmlns:a16="http://schemas.microsoft.com/office/drawing/2014/main" id="{6EDDD811-29E5-471B-8FCD-A507374C77C1}"/>
+                <a16:creationId xmlns:a16="http://schemas.microsoft.com/office/drawing/2014/main" id="{510C8D32-1466-4503-B6AB-8C79B371831B}"/>
               </a:ext>
             </a:extLst>
           </p:cNvPr>
@@ -4223,7 +4223,7 @@
           <p:cNvPr id="10" name="">
             <a:extLst xmlns:a="http://schemas.openxmlformats.org/drawingml/2006/main">
               <a:ext uri="{FF2B5EF4-FFF2-40B4-BE49-F238E27FC236}">
-                <a16:creationId xmlns:a16="http://schemas.microsoft.com/office/drawing/2014/main" id="{246A4F54-9220-447A-A746-4FA315A56ADD}"/>
+                <a16:creationId xmlns:a16="http://schemas.microsoft.com/office/drawing/2014/main" id="{768CC599-8A9C-43A0-8599-E29159400E17}"/>
               </a:ext>
             </a:extLst>
           </p:cNvPr>
@@ -4280,7 +4280,7 @@
           <p:cNvPr id="11" name="">
             <a:extLst xmlns:a="http://schemas.openxmlformats.org/drawingml/2006/main">
               <a:ext uri="{FF2B5EF4-FFF2-40B4-BE49-F238E27FC236}">
-                <a16:creationId xmlns:a16="http://schemas.microsoft.com/office/drawing/2014/main" id="{8FB6C606-EE3A-4E18-A988-4260BA875CC0}"/>
+                <a16:creationId xmlns:a16="http://schemas.microsoft.com/office/drawing/2014/main" id="{A3DC7F93-A092-4FC4-9F34-79F74A684967}"/>
               </a:ext>
             </a:extLst>
           </p:cNvPr>
@@ -4337,7 +4337,7 @@
           <p:cNvPr id="12" name="">
             <a:extLst xmlns:a="http://schemas.openxmlformats.org/drawingml/2006/main">
               <a:ext uri="{FF2B5EF4-FFF2-40B4-BE49-F238E27FC236}">
-                <a16:creationId xmlns:a16="http://schemas.microsoft.com/office/drawing/2014/main" id="{2076948A-FC4C-4605-9EA7-65CBF9A65C96}"/>
+                <a16:creationId xmlns:a16="http://schemas.microsoft.com/office/drawing/2014/main" id="{BAE0A12C-9A81-4F02-9A8C-2B5F585FE747}"/>
               </a:ext>
             </a:extLst>
           </p:cNvPr>
@@ -4394,7 +4394,7 @@
           <p:cNvPr id="13" name="">
             <a:extLst xmlns:a="http://schemas.openxmlformats.org/drawingml/2006/main">
               <a:ext uri="{FF2B5EF4-FFF2-40B4-BE49-F238E27FC236}">
-                <a16:creationId xmlns:a16="http://schemas.microsoft.com/office/drawing/2014/main" id="{AD1F3EA8-3DAC-4047-B8E7-CA9553F9B402}"/>
+                <a16:creationId xmlns:a16="http://schemas.microsoft.com/office/drawing/2014/main" id="{17623CEE-4402-40BF-9EB2-2CFD05756EDE}"/>
               </a:ext>
             </a:extLst>
           </p:cNvPr>
@@ -4451,7 +4451,7 @@
           <p:cNvPr id="14" name="">
             <a:extLst xmlns:a="http://schemas.openxmlformats.org/drawingml/2006/main">
               <a:ext uri="{FF2B5EF4-FFF2-40B4-BE49-F238E27FC236}">
-                <a16:creationId xmlns:a16="http://schemas.microsoft.com/office/drawing/2014/main" id="{F71C0219-EA1F-46AD-BC95-D5176C47163F}"/>
+                <a16:creationId xmlns:a16="http://schemas.microsoft.com/office/drawing/2014/main" id="{7F46391D-D4B0-47EE-ACFC-1FB59B8E0AD1}"/>
               </a:ext>
             </a:extLst>
           </p:cNvPr>
@@ -4508,7 +4508,7 @@
           <p:cNvPr id="15" name="">
             <a:extLst xmlns:a="http://schemas.openxmlformats.org/drawingml/2006/main">
               <a:ext uri="{FF2B5EF4-FFF2-40B4-BE49-F238E27FC236}">
-                <a16:creationId xmlns:a16="http://schemas.microsoft.com/office/drawing/2014/main" id="{9CF04199-FEC5-43B9-ABFA-640EDCBC2D40}"/>
+                <a16:creationId xmlns:a16="http://schemas.microsoft.com/office/drawing/2014/main" id="{44FCDE31-C867-437C-90BB-F38BAE8FD217}"/>
               </a:ext>
             </a:extLst>
           </p:cNvPr>
@@ -4542,7 +4542,7 @@
           <p:cNvPr id="16" name="">
             <a:extLst xmlns:a="http://schemas.openxmlformats.org/drawingml/2006/main">
               <a:ext uri="{FF2B5EF4-FFF2-40B4-BE49-F238E27FC236}">
-                <a16:creationId xmlns:a16="http://schemas.microsoft.com/office/drawing/2014/main" id="{DE498ADE-6D5F-4E28-827B-B4EAB79AAC6F}"/>
+                <a16:creationId xmlns:a16="http://schemas.microsoft.com/office/drawing/2014/main" id="{95F45926-99B7-4E57-9EE2-66012D77D8A4}"/>
               </a:ext>
             </a:extLst>
           </p:cNvPr>
@@ -4599,7 +4599,7 @@
           <p:cNvPr id="17" name="">
             <a:extLst xmlns:a="http://schemas.openxmlformats.org/drawingml/2006/main">
               <a:ext uri="{FF2B5EF4-FFF2-40B4-BE49-F238E27FC236}">
-                <a16:creationId xmlns:a16="http://schemas.microsoft.com/office/drawing/2014/main" id="{01D96BDB-6FD2-4E9A-A842-E27745DDF30C}"/>
+                <a16:creationId xmlns:a16="http://schemas.microsoft.com/office/drawing/2014/main" id="{2D9E39C0-6EFB-4361-B906-43864F6A9B78}"/>
               </a:ext>
             </a:extLst>
           </p:cNvPr>
@@ -4748,7 +4748,7 @@
           <p:cNvPr id="18" name="">
             <a:extLst xmlns:a="http://schemas.openxmlformats.org/drawingml/2006/main">
               <a:ext uri="{FF2B5EF4-FFF2-40B4-BE49-F238E27FC236}">
-                <a16:creationId xmlns:a16="http://schemas.microsoft.com/office/drawing/2014/main" id="{7C2810FE-E278-4C34-94FB-4ECB842F9F55}"/>
+                <a16:creationId xmlns:a16="http://schemas.microsoft.com/office/drawing/2014/main" id="{306DE600-DF73-4A3E-A58C-75A2395628F7}"/>
               </a:ext>
             </a:extLst>
           </p:cNvPr>
@@ -4766,7 +4766,7 @@
             <a:avLst/>
           </a:prstGeom>
           <a:solidFill xmlns:a="http://schemas.openxmlformats.org/drawingml/2006/main">
-            <a:srgbClr val="D32F2F"/>
+            <a:srgbClr val="59A14F"/>
           </a:solidFill>
           <a:ln xmlns:a="http://schemas.openxmlformats.org/drawingml/2006/main" w="0">
             <a:noFill/>
@@ -4779,7 +4779,7 @@
           <a:lstStyle xmlns:a="http://schemas.openxmlformats.org/drawingml/2006/main"/>
           <a:p xmlns:a="http://schemas.openxmlformats.org/drawingml/2006/main">
             <a:pPr algn="ctr">
-              <a:defRPr sz="1575" b="1">
+              <a:defRPr sz="1350" b="1">
                 <a:solidFill>
                   <a:srgbClr val="FFFFFF"/>
                 </a:solidFill>
@@ -4789,7 +4789,7 @@
               </a:defRPr>
             </a:pPr>
             <a:r>
-              <a:rPr sz="1575" b="1">
+              <a:rPr sz="1350" b="1">
                 <a:solidFill>
                   <a:srgbClr val="FFFFFF"/>
                 </a:solidFill>
@@ -4797,7 +4797,7 @@
                 <a:ea typeface="Arial"/>
                 <a:cs typeface="Arial"/>
               </a:rPr>
-              <a:t>GitHub: chờ URL repository thật trước khi nộp</a:t>
+              <a:t>GitHub: https://github.com/tranthinhhhh/AIoT-D18-WESAD-22110236</a:t>
             </a:r>
           </a:p>
         </p:txBody>
@@ -4807,7 +4807,7 @@
           <p:cNvPr id="19" name="">
             <a:extLst xmlns:a="http://schemas.openxmlformats.org/drawingml/2006/main">
               <a:ext uri="{FF2B5EF4-FFF2-40B4-BE49-F238E27FC236}">
-                <a16:creationId xmlns:a16="http://schemas.microsoft.com/office/drawing/2014/main" id="{CF9275D6-C065-44ED-855D-7498A9AB665E}"/>
+                <a16:creationId xmlns:a16="http://schemas.microsoft.com/office/drawing/2014/main" id="{8C4FE905-FCB2-45BA-9D3E-A51979179183}"/>
               </a:ext>
             </a:extLst>
           </p:cNvPr>
@@ -4862,7 +4862,7 @@
     </p:spTree>
     <p:extLst>
       <p:ext uri="{BB962C8B-B14F-4D97-AF65-F5344CB8AC3E}">
-        <p14:creationId xmlns:p14="http://schemas.microsoft.com/office/powerpoint/2010/main" val="743745779"/>
+        <p14:creationId xmlns:p14="http://schemas.microsoft.com/office/powerpoint/2010/main" val="327746909"/>
       </p:ext>
     </p:extLst>
   </p:cSld>
@@ -4893,7 +4893,7 @@
           <p:cNvPr id="21" name="">
             <a:extLst xmlns:a="http://schemas.openxmlformats.org/drawingml/2006/main">
               <a:ext uri="{FF2B5EF4-FFF2-40B4-BE49-F238E27FC236}">
-                <a16:creationId xmlns:a16="http://schemas.microsoft.com/office/drawing/2014/main" id="{442CDFCA-BAD8-4971-810C-74A88AE0D189}"/>
+                <a16:creationId xmlns:a16="http://schemas.microsoft.com/office/drawing/2014/main" id="{C27DAB30-F5AB-4E64-A8A3-DBFF40133612}"/>
               </a:ext>
             </a:extLst>
           </p:cNvPr>
@@ -4950,7 +4950,7 @@
           <p:cNvPr id="2" name="">
             <a:extLst xmlns:a="http://schemas.openxmlformats.org/drawingml/2006/main">
               <a:ext uri="{FF2B5EF4-FFF2-40B4-BE49-F238E27FC236}">
-                <a16:creationId xmlns:a16="http://schemas.microsoft.com/office/drawing/2014/main" id="{59611CEB-7D7F-498C-9D20-D421377CB9FE}"/>
+                <a16:creationId xmlns:a16="http://schemas.microsoft.com/office/drawing/2014/main" id="{394C5991-8D98-4A77-A939-9A04D09F9EA4}"/>
               </a:ext>
             </a:extLst>
           </p:cNvPr>
@@ -4980,7 +4980,7 @@
           <p:cNvPr id="3" name="">
             <a:extLst xmlns:a="http://schemas.openxmlformats.org/drawingml/2006/main">
               <a:ext uri="{FF2B5EF4-FFF2-40B4-BE49-F238E27FC236}">
-                <a16:creationId xmlns:a16="http://schemas.microsoft.com/office/drawing/2014/main" id="{816FD29E-A6EE-49BD-9BFB-542EA7FDFEFE}"/>
+                <a16:creationId xmlns:a16="http://schemas.microsoft.com/office/drawing/2014/main" id="{C33FD646-A2EE-4E25-B6ED-7290C054C2CF}"/>
               </a:ext>
             </a:extLst>
           </p:cNvPr>
@@ -5037,7 +5037,7 @@
           <p:cNvPr id="4" name="">
             <a:extLst xmlns:a="http://schemas.openxmlformats.org/drawingml/2006/main">
               <a:ext uri="{FF2B5EF4-FFF2-40B4-BE49-F238E27FC236}">
-                <a16:creationId xmlns:a16="http://schemas.microsoft.com/office/drawing/2014/main" id="{E636ED3A-D2FA-465E-9CAC-C183F95F94D4}"/>
+                <a16:creationId xmlns:a16="http://schemas.microsoft.com/office/drawing/2014/main" id="{F2326272-161A-47D1-9CEE-609942EA8AB7}"/>
               </a:ext>
             </a:extLst>
           </p:cNvPr>
@@ -5094,7 +5094,7 @@
           <p:cNvPr id="5" name="">
             <a:extLst xmlns:a="http://schemas.openxmlformats.org/drawingml/2006/main">
               <a:ext uri="{FF2B5EF4-FFF2-40B4-BE49-F238E27FC236}">
-                <a16:creationId xmlns:a16="http://schemas.microsoft.com/office/drawing/2014/main" id="{5F1042D7-B40D-4FBE-8221-582BCA301F9A}"/>
+                <a16:creationId xmlns:a16="http://schemas.microsoft.com/office/drawing/2014/main" id="{2B1E5BB3-941E-4697-8210-7FD41D8FC7EF}"/>
               </a:ext>
             </a:extLst>
           </p:cNvPr>
@@ -5176,7 +5176,7 @@
           <p:cNvPr id="6" name="">
             <a:extLst xmlns:a="http://schemas.openxmlformats.org/drawingml/2006/main">
               <a:ext uri="{FF2B5EF4-FFF2-40B4-BE49-F238E27FC236}">
-                <a16:creationId xmlns:a16="http://schemas.microsoft.com/office/drawing/2014/main" id="{DE3F7040-3504-48F4-BF02-029915C5F44A}"/>
+                <a16:creationId xmlns:a16="http://schemas.microsoft.com/office/drawing/2014/main" id="{E8DBA5AB-238C-4450-9051-77D202D607DC}"/>
               </a:ext>
             </a:extLst>
           </p:cNvPr>
@@ -5206,7 +5206,7 @@
           <p:cNvPr id="7" name="">
             <a:extLst xmlns:a="http://schemas.openxmlformats.org/drawingml/2006/main">
               <a:ext uri="{FF2B5EF4-FFF2-40B4-BE49-F238E27FC236}">
-                <a16:creationId xmlns:a16="http://schemas.microsoft.com/office/drawing/2014/main" id="{99771EFD-46CE-47CD-A733-2DF88F4ACC24}"/>
+                <a16:creationId xmlns:a16="http://schemas.microsoft.com/office/drawing/2014/main" id="{ADD30B0B-2883-4BF7-80EF-475AEDF1B276}"/>
               </a:ext>
             </a:extLst>
           </p:cNvPr>
@@ -5265,7 +5265,7 @@
           <p:cNvPr id="8" name="">
             <a:extLst xmlns:a="http://schemas.openxmlformats.org/drawingml/2006/main">
               <a:ext uri="{FF2B5EF4-FFF2-40B4-BE49-F238E27FC236}">
-                <a16:creationId xmlns:a16="http://schemas.microsoft.com/office/drawing/2014/main" id="{B5AFBD16-258D-427F-A203-9856BCDCC12F}"/>
+                <a16:creationId xmlns:a16="http://schemas.microsoft.com/office/drawing/2014/main" id="{123A7BF9-D232-4E8F-A3C4-CFA411E013F2}"/>
               </a:ext>
             </a:extLst>
           </p:cNvPr>
@@ -5295,7 +5295,7 @@
           <p:cNvPr id="9" name="">
             <a:extLst xmlns:a="http://schemas.openxmlformats.org/drawingml/2006/main">
               <a:ext uri="{FF2B5EF4-FFF2-40B4-BE49-F238E27FC236}">
-                <a16:creationId xmlns:a16="http://schemas.microsoft.com/office/drawing/2014/main" id="{E1EFFF65-EF47-479B-9F5E-53940839F538}"/>
+                <a16:creationId xmlns:a16="http://schemas.microsoft.com/office/drawing/2014/main" id="{C147B79A-12D4-4EAD-BA1B-161D9D4F09FE}"/>
               </a:ext>
             </a:extLst>
           </p:cNvPr>
@@ -5377,7 +5377,7 @@
           <p:cNvPr id="10" name="">
             <a:extLst xmlns:a="http://schemas.openxmlformats.org/drawingml/2006/main">
               <a:ext uri="{FF2B5EF4-FFF2-40B4-BE49-F238E27FC236}">
-                <a16:creationId xmlns:a16="http://schemas.microsoft.com/office/drawing/2014/main" id="{959C99A1-C2EC-466D-9CB0-CF824ACF0C79}"/>
+                <a16:creationId xmlns:a16="http://schemas.microsoft.com/office/drawing/2014/main" id="{DD4B503A-8135-4687-9993-7D78FF9AFB97}"/>
               </a:ext>
             </a:extLst>
           </p:cNvPr>
@@ -5434,7 +5434,7 @@
           <p:cNvPr id="11" name="">
             <a:extLst xmlns:a="http://schemas.openxmlformats.org/drawingml/2006/main">
               <a:ext uri="{FF2B5EF4-FFF2-40B4-BE49-F238E27FC236}">
-                <a16:creationId xmlns:a16="http://schemas.microsoft.com/office/drawing/2014/main" id="{424A783D-562D-4A46-A1FF-1CA769BFD606}"/>
+                <a16:creationId xmlns:a16="http://schemas.microsoft.com/office/drawing/2014/main" id="{B57019D5-1A3D-4B30-9147-98965706038D}"/>
               </a:ext>
             </a:extLst>
           </p:cNvPr>
@@ -5493,7 +5493,7 @@
           <p:cNvPr id="12" name="">
             <a:extLst xmlns:a="http://schemas.openxmlformats.org/drawingml/2006/main">
               <a:ext uri="{FF2B5EF4-FFF2-40B4-BE49-F238E27FC236}">
-                <a16:creationId xmlns:a16="http://schemas.microsoft.com/office/drawing/2014/main" id="{D11B2A24-68A2-4C14-978A-66DABAEB7649}"/>
+                <a16:creationId xmlns:a16="http://schemas.microsoft.com/office/drawing/2014/main" id="{EA53763A-CF40-4F06-8BB8-9A447F1073B6}"/>
               </a:ext>
             </a:extLst>
           </p:cNvPr>
@@ -5575,7 +5575,7 @@
           <p:cNvPr id="13" name="">
             <a:extLst xmlns:a="http://schemas.openxmlformats.org/drawingml/2006/main">
               <a:ext uri="{FF2B5EF4-FFF2-40B4-BE49-F238E27FC236}">
-                <a16:creationId xmlns:a16="http://schemas.microsoft.com/office/drawing/2014/main" id="{E1D4B872-B36D-424F-9AF4-E42AA9BDB608}"/>
+                <a16:creationId xmlns:a16="http://schemas.microsoft.com/office/drawing/2014/main" id="{22F10DD6-B391-4490-AAA7-B585C563A4EB}"/>
               </a:ext>
             </a:extLst>
           </p:cNvPr>
@@ -5634,7 +5634,7 @@
           <p:cNvPr id="14" name="">
             <a:extLst xmlns:a="http://schemas.openxmlformats.org/drawingml/2006/main">
               <a:ext uri="{FF2B5EF4-FFF2-40B4-BE49-F238E27FC236}">
-                <a16:creationId xmlns:a16="http://schemas.microsoft.com/office/drawing/2014/main" id="{4A41B048-48C7-4CB7-AC37-C90D372A0D14}"/>
+                <a16:creationId xmlns:a16="http://schemas.microsoft.com/office/drawing/2014/main" id="{4520ED4F-170D-4185-BDB9-62A4ED1BB8AB}"/>
               </a:ext>
             </a:extLst>
           </p:cNvPr>
@@ -5716,7 +5716,7 @@
           <p:cNvPr id="15" name="">
             <a:extLst xmlns:a="http://schemas.openxmlformats.org/drawingml/2006/main">
               <a:ext uri="{FF2B5EF4-FFF2-40B4-BE49-F238E27FC236}">
-                <a16:creationId xmlns:a16="http://schemas.microsoft.com/office/drawing/2014/main" id="{9BC6ACBC-5F3E-469D-8469-1E759A855477}"/>
+                <a16:creationId xmlns:a16="http://schemas.microsoft.com/office/drawing/2014/main" id="{811FEF65-C6AE-4CFB-8C43-35F800E9F7B5}"/>
               </a:ext>
             </a:extLst>
           </p:cNvPr>
@@ -5775,7 +5775,7 @@
           <p:cNvPr id="16" name="">
             <a:extLst xmlns:a="http://schemas.openxmlformats.org/drawingml/2006/main">
               <a:ext uri="{FF2B5EF4-FFF2-40B4-BE49-F238E27FC236}">
-                <a16:creationId xmlns:a16="http://schemas.microsoft.com/office/drawing/2014/main" id="{7ADDE0CC-0419-40BA-90E2-02A402FBCB32}"/>
+                <a16:creationId xmlns:a16="http://schemas.microsoft.com/office/drawing/2014/main" id="{D6D4E236-6B41-4EBC-BC76-9DBB78E1A089}"/>
               </a:ext>
             </a:extLst>
           </p:cNvPr>
@@ -5857,7 +5857,7 @@
           <p:cNvPr id="17" name="">
             <a:extLst xmlns:a="http://schemas.openxmlformats.org/drawingml/2006/main">
               <a:ext uri="{FF2B5EF4-FFF2-40B4-BE49-F238E27FC236}">
-                <a16:creationId xmlns:a16="http://schemas.microsoft.com/office/drawing/2014/main" id="{43870045-F8B5-45EF-8EB6-A80D512B5ED3}"/>
+                <a16:creationId xmlns:a16="http://schemas.microsoft.com/office/drawing/2014/main" id="{CD873356-F30E-435C-B191-09795AB4EB45}"/>
               </a:ext>
             </a:extLst>
           </p:cNvPr>
@@ -5916,7 +5916,7 @@
           <p:cNvPr id="18" name="">
             <a:extLst xmlns:a="http://schemas.openxmlformats.org/drawingml/2006/main">
               <a:ext uri="{FF2B5EF4-FFF2-40B4-BE49-F238E27FC236}">
-                <a16:creationId xmlns:a16="http://schemas.microsoft.com/office/drawing/2014/main" id="{E0532AC6-CC5F-4613-AD8F-224AC570A46D}"/>
+                <a16:creationId xmlns:a16="http://schemas.microsoft.com/office/drawing/2014/main" id="{86479E42-8B7C-481C-9287-B425E6ABCBCA}"/>
               </a:ext>
             </a:extLst>
           </p:cNvPr>
@@ -5946,7 +5946,7 @@
           <p:cNvPr id="19" name="">
             <a:extLst xmlns:a="http://schemas.openxmlformats.org/drawingml/2006/main">
               <a:ext uri="{FF2B5EF4-FFF2-40B4-BE49-F238E27FC236}">
-                <a16:creationId xmlns:a16="http://schemas.microsoft.com/office/drawing/2014/main" id="{E99547FE-617E-4503-BE06-928CBB968428}"/>
+                <a16:creationId xmlns:a16="http://schemas.microsoft.com/office/drawing/2014/main" id="{ADF5EDD9-75FF-4EB6-871D-E8B7355B666A}"/>
               </a:ext>
             </a:extLst>
           </p:cNvPr>
@@ -6003,7 +6003,7 @@
           <p:cNvPr id="20" name="">
             <a:extLst xmlns:a="http://schemas.openxmlformats.org/drawingml/2006/main">
               <a:ext uri="{FF2B5EF4-FFF2-40B4-BE49-F238E27FC236}">
-                <a16:creationId xmlns:a16="http://schemas.microsoft.com/office/drawing/2014/main" id="{8BE4E1CF-8913-43CF-8078-2CDD3DB166B0}"/>
+                <a16:creationId xmlns:a16="http://schemas.microsoft.com/office/drawing/2014/main" id="{63EFE8A1-04BB-48F8-9CA6-D2A46F41686B}"/>
               </a:ext>
             </a:extLst>
           </p:cNvPr>
@@ -6058,7 +6058,7 @@
     </p:spTree>
     <p:extLst>
       <p:ext uri="{BB962C8B-B14F-4D97-AF65-F5344CB8AC3E}">
-        <p14:creationId xmlns:p14="http://schemas.microsoft.com/office/powerpoint/2010/main" val="340552028"/>
+        <p14:creationId xmlns:p14="http://schemas.microsoft.com/office/powerpoint/2010/main" val="1031164140"/>
       </p:ext>
     </p:extLst>
   </p:cSld>
@@ -6089,7 +6089,7 @@
           <p:cNvPr id="41" name="">
             <a:extLst xmlns:a="http://schemas.openxmlformats.org/drawingml/2006/main">
               <a:ext uri="{FF2B5EF4-FFF2-40B4-BE49-F238E27FC236}">
-                <a16:creationId xmlns:a16="http://schemas.microsoft.com/office/drawing/2014/main" id="{CFF481EF-349D-467D-8073-6A2B038BBADF}"/>
+                <a16:creationId xmlns:a16="http://schemas.microsoft.com/office/drawing/2014/main" id="{9C7D39EA-7933-4F15-A97E-1C22A828A428}"/>
               </a:ext>
             </a:extLst>
           </p:cNvPr>
@@ -6146,7 +6146,7 @@
           <p:cNvPr id="2" name="">
             <a:extLst xmlns:a="http://schemas.openxmlformats.org/drawingml/2006/main">
               <a:ext uri="{FF2B5EF4-FFF2-40B4-BE49-F238E27FC236}">
-                <a16:creationId xmlns:a16="http://schemas.microsoft.com/office/drawing/2014/main" id="{1A232BD5-BDF4-43EA-974A-74FF07C1D8AE}"/>
+                <a16:creationId xmlns:a16="http://schemas.microsoft.com/office/drawing/2014/main" id="{11E65F30-2EDE-425F-B844-75BE1517AA4C}"/>
               </a:ext>
             </a:extLst>
           </p:cNvPr>
@@ -6176,7 +6176,7 @@
           <p:cNvPr id="3" name="">
             <a:extLst xmlns:a="http://schemas.openxmlformats.org/drawingml/2006/main">
               <a:ext uri="{FF2B5EF4-FFF2-40B4-BE49-F238E27FC236}">
-                <a16:creationId xmlns:a16="http://schemas.microsoft.com/office/drawing/2014/main" id="{F16FE97A-65DB-46D9-B7EA-3B78817CD406}"/>
+                <a16:creationId xmlns:a16="http://schemas.microsoft.com/office/drawing/2014/main" id="{E212FB20-76FE-4E7B-A223-0D0AC623980E}"/>
               </a:ext>
             </a:extLst>
           </p:cNvPr>
@@ -6233,7 +6233,7 @@
           <p:cNvPr id="4" name="">
             <a:extLst xmlns:a="http://schemas.openxmlformats.org/drawingml/2006/main">
               <a:ext uri="{FF2B5EF4-FFF2-40B4-BE49-F238E27FC236}">
-                <a16:creationId xmlns:a16="http://schemas.microsoft.com/office/drawing/2014/main" id="{588FC08E-A28E-4346-8082-273131A41562}"/>
+                <a16:creationId xmlns:a16="http://schemas.microsoft.com/office/drawing/2014/main" id="{9F43FFA5-79E0-4C85-9C0F-463F1C313BDF}"/>
               </a:ext>
             </a:extLst>
           </p:cNvPr>
@@ -6267,7 +6267,7 @@
           <p:cNvPr id="5" name="">
             <a:extLst xmlns:a="http://schemas.openxmlformats.org/drawingml/2006/main">
               <a:ext uri="{FF2B5EF4-FFF2-40B4-BE49-F238E27FC236}">
-                <a16:creationId xmlns:a16="http://schemas.microsoft.com/office/drawing/2014/main" id="{981FF88B-FA2E-4AC9-BDE4-E32F63FA9F0A}"/>
+                <a16:creationId xmlns:a16="http://schemas.microsoft.com/office/drawing/2014/main" id="{766356D6-5851-4A02-9BAF-DCF979DB6B9B}"/>
               </a:ext>
             </a:extLst>
           </p:cNvPr>
@@ -6326,7 +6326,7 @@
           <p:cNvPr id="6" name="">
             <a:extLst xmlns:a="http://schemas.openxmlformats.org/drawingml/2006/main">
               <a:ext uri="{FF2B5EF4-FFF2-40B4-BE49-F238E27FC236}">
-                <a16:creationId xmlns:a16="http://schemas.microsoft.com/office/drawing/2014/main" id="{B2F74DC7-5824-4FDB-B34C-DDF62F27A5B8}"/>
+                <a16:creationId xmlns:a16="http://schemas.microsoft.com/office/drawing/2014/main" id="{8ED821A3-533F-49C5-BA92-AE99BDE9AAAA}"/>
               </a:ext>
             </a:extLst>
           </p:cNvPr>
@@ -6383,7 +6383,7 @@
           <p:cNvPr id="7" name="">
             <a:extLst xmlns:a="http://schemas.openxmlformats.org/drawingml/2006/main">
               <a:ext uri="{FF2B5EF4-FFF2-40B4-BE49-F238E27FC236}">
-                <a16:creationId xmlns:a16="http://schemas.microsoft.com/office/drawing/2014/main" id="{F435EAED-C18C-4E90-99EE-27F60F12812A}"/>
+                <a16:creationId xmlns:a16="http://schemas.microsoft.com/office/drawing/2014/main" id="{22BC3D9D-EA14-4B5D-8F83-692BEC046BCB}"/>
               </a:ext>
             </a:extLst>
           </p:cNvPr>
@@ -6463,7 +6463,7 @@
           <p:cNvPr id="8" name="">
             <a:extLst xmlns:a="http://schemas.openxmlformats.org/drawingml/2006/main">
               <a:ext uri="{FF2B5EF4-FFF2-40B4-BE49-F238E27FC236}">
-                <a16:creationId xmlns:a16="http://schemas.microsoft.com/office/drawing/2014/main" id="{270840FA-421E-4883-ACD7-21FF0D25C91F}"/>
+                <a16:creationId xmlns:a16="http://schemas.microsoft.com/office/drawing/2014/main" id="{B908372F-9520-476E-84E0-DC0F78683F02}"/>
               </a:ext>
             </a:extLst>
           </p:cNvPr>
@@ -6493,7 +6493,7 @@
           <p:cNvPr id="9" name="">
             <a:extLst xmlns:a="http://schemas.openxmlformats.org/drawingml/2006/main">
               <a:ext uri="{FF2B5EF4-FFF2-40B4-BE49-F238E27FC236}">
-                <a16:creationId xmlns:a16="http://schemas.microsoft.com/office/drawing/2014/main" id="{07E5EBDA-A732-4142-A581-9984E60BA625}"/>
+                <a16:creationId xmlns:a16="http://schemas.microsoft.com/office/drawing/2014/main" id="{9F0324F9-81E6-4B5C-954B-5196A31A0D4E}"/>
               </a:ext>
             </a:extLst>
           </p:cNvPr>
@@ -6527,7 +6527,7 @@
           <p:cNvPr id="10" name="">
             <a:extLst xmlns:a="http://schemas.openxmlformats.org/drawingml/2006/main">
               <a:ext uri="{FF2B5EF4-FFF2-40B4-BE49-F238E27FC236}">
-                <a16:creationId xmlns:a16="http://schemas.microsoft.com/office/drawing/2014/main" id="{0C87BD54-F473-49A2-BBD1-77F95AE3716B}"/>
+                <a16:creationId xmlns:a16="http://schemas.microsoft.com/office/drawing/2014/main" id="{244D219B-F7A0-467C-B925-A9B74E1DE619}"/>
               </a:ext>
             </a:extLst>
           </p:cNvPr>
@@ -6586,7 +6586,7 @@
           <p:cNvPr id="11" name="">
             <a:extLst xmlns:a="http://schemas.openxmlformats.org/drawingml/2006/main">
               <a:ext uri="{FF2B5EF4-FFF2-40B4-BE49-F238E27FC236}">
-                <a16:creationId xmlns:a16="http://schemas.microsoft.com/office/drawing/2014/main" id="{6791E856-44E1-44FE-B2E2-6DDEAAE74984}"/>
+                <a16:creationId xmlns:a16="http://schemas.microsoft.com/office/drawing/2014/main" id="{B42BB1B9-556E-4FD5-9EF3-C31231B3F166}"/>
               </a:ext>
             </a:extLst>
           </p:cNvPr>
@@ -6643,7 +6643,7 @@
           <p:cNvPr id="12" name="">
             <a:extLst xmlns:a="http://schemas.openxmlformats.org/drawingml/2006/main">
               <a:ext uri="{FF2B5EF4-FFF2-40B4-BE49-F238E27FC236}">
-                <a16:creationId xmlns:a16="http://schemas.microsoft.com/office/drawing/2014/main" id="{5C63F0F8-E638-4E14-89FF-22466F4D50FF}"/>
+                <a16:creationId xmlns:a16="http://schemas.microsoft.com/office/drawing/2014/main" id="{1A44FA11-BFBC-455D-A185-27BBCC4F0E58}"/>
               </a:ext>
             </a:extLst>
           </p:cNvPr>
@@ -6723,7 +6723,7 @@
           <p:cNvPr id="13" name="">
             <a:extLst xmlns:a="http://schemas.openxmlformats.org/drawingml/2006/main">
               <a:ext uri="{FF2B5EF4-FFF2-40B4-BE49-F238E27FC236}">
-                <a16:creationId xmlns:a16="http://schemas.microsoft.com/office/drawing/2014/main" id="{1F607613-7DDE-4B7E-9C41-DD301357B3DF}"/>
+                <a16:creationId xmlns:a16="http://schemas.microsoft.com/office/drawing/2014/main" id="{300B12F1-9E2C-40A9-B6B5-2FBF11FC2BE7}"/>
               </a:ext>
             </a:extLst>
           </p:cNvPr>
@@ -6753,7 +6753,7 @@
           <p:cNvPr id="14" name="">
             <a:extLst xmlns:a="http://schemas.openxmlformats.org/drawingml/2006/main">
               <a:ext uri="{FF2B5EF4-FFF2-40B4-BE49-F238E27FC236}">
-                <a16:creationId xmlns:a16="http://schemas.microsoft.com/office/drawing/2014/main" id="{9EF07911-BF72-459D-AF5B-B3BF5085F0B9}"/>
+                <a16:creationId xmlns:a16="http://schemas.microsoft.com/office/drawing/2014/main" id="{7BC232BD-EA55-4AA2-909D-49F845EB1EA8}"/>
               </a:ext>
             </a:extLst>
           </p:cNvPr>
@@ -6787,7 +6787,7 @@
           <p:cNvPr id="15" name="">
             <a:extLst xmlns:a="http://schemas.openxmlformats.org/drawingml/2006/main">
               <a:ext uri="{FF2B5EF4-FFF2-40B4-BE49-F238E27FC236}">
-                <a16:creationId xmlns:a16="http://schemas.microsoft.com/office/drawing/2014/main" id="{A8E82091-0774-47E8-A12D-11DE5AB52911}"/>
+                <a16:creationId xmlns:a16="http://schemas.microsoft.com/office/drawing/2014/main" id="{4E124787-17FD-432A-8C20-DD28CF16F224}"/>
               </a:ext>
             </a:extLst>
           </p:cNvPr>
@@ -6846,7 +6846,7 @@
           <p:cNvPr id="16" name="">
             <a:extLst xmlns:a="http://schemas.openxmlformats.org/drawingml/2006/main">
               <a:ext uri="{FF2B5EF4-FFF2-40B4-BE49-F238E27FC236}">
-                <a16:creationId xmlns:a16="http://schemas.microsoft.com/office/drawing/2014/main" id="{6BABA6F7-B1A5-4829-A49B-0911F14A5E1F}"/>
+                <a16:creationId xmlns:a16="http://schemas.microsoft.com/office/drawing/2014/main" id="{648EE6AB-48CC-4EEB-82C0-1B15F65FEC7F}"/>
               </a:ext>
             </a:extLst>
           </p:cNvPr>
@@ -6903,7 +6903,7 @@
           <p:cNvPr id="17" name="">
             <a:extLst xmlns:a="http://schemas.openxmlformats.org/drawingml/2006/main">
               <a:ext uri="{FF2B5EF4-FFF2-40B4-BE49-F238E27FC236}">
-                <a16:creationId xmlns:a16="http://schemas.microsoft.com/office/drawing/2014/main" id="{4CBED1D8-7327-491D-A480-739E79B21B10}"/>
+                <a16:creationId xmlns:a16="http://schemas.microsoft.com/office/drawing/2014/main" id="{3963A356-EC73-4AE0-B627-386ADF3F391A}"/>
               </a:ext>
             </a:extLst>
           </p:cNvPr>
@@ -6983,7 +6983,7 @@
           <p:cNvPr id="18" name="">
             <a:extLst xmlns:a="http://schemas.openxmlformats.org/drawingml/2006/main">
               <a:ext uri="{FF2B5EF4-FFF2-40B4-BE49-F238E27FC236}">
-                <a16:creationId xmlns:a16="http://schemas.microsoft.com/office/drawing/2014/main" id="{F9F08F5D-D3A0-47C9-B23B-DF01AB5B0035}"/>
+                <a16:creationId xmlns:a16="http://schemas.microsoft.com/office/drawing/2014/main" id="{64A7D8AD-DE40-423E-9F56-55495AF9D2E7}"/>
               </a:ext>
             </a:extLst>
           </p:cNvPr>
@@ -7013,7 +7013,7 @@
           <p:cNvPr id="19" name="">
             <a:extLst xmlns:a="http://schemas.openxmlformats.org/drawingml/2006/main">
               <a:ext uri="{FF2B5EF4-FFF2-40B4-BE49-F238E27FC236}">
-                <a16:creationId xmlns:a16="http://schemas.microsoft.com/office/drawing/2014/main" id="{C3ED6AB5-B44D-424A-B595-FDA92C837B2A}"/>
+                <a16:creationId xmlns:a16="http://schemas.microsoft.com/office/drawing/2014/main" id="{A9A498CB-648E-47D9-B0DF-1F532F475EA3}"/>
               </a:ext>
             </a:extLst>
           </p:cNvPr>
@@ -7047,7 +7047,7 @@
           <p:cNvPr id="20" name="">
             <a:extLst xmlns:a="http://schemas.openxmlformats.org/drawingml/2006/main">
               <a:ext uri="{FF2B5EF4-FFF2-40B4-BE49-F238E27FC236}">
-                <a16:creationId xmlns:a16="http://schemas.microsoft.com/office/drawing/2014/main" id="{7CB0635C-139D-4A59-9ECD-B6E6104409DF}"/>
+                <a16:creationId xmlns:a16="http://schemas.microsoft.com/office/drawing/2014/main" id="{C01953E0-FD84-46D3-B081-8E004082C299}"/>
               </a:ext>
             </a:extLst>
           </p:cNvPr>
@@ -7106,7 +7106,7 @@
           <p:cNvPr id="21" name="">
             <a:extLst xmlns:a="http://schemas.openxmlformats.org/drawingml/2006/main">
               <a:ext uri="{FF2B5EF4-FFF2-40B4-BE49-F238E27FC236}">
-                <a16:creationId xmlns:a16="http://schemas.microsoft.com/office/drawing/2014/main" id="{5F96361B-9993-4B9C-B027-21BFCC7558CF}"/>
+                <a16:creationId xmlns:a16="http://schemas.microsoft.com/office/drawing/2014/main" id="{F72929DF-557E-49AF-BBBF-1A0F2E98BEC6}"/>
               </a:ext>
             </a:extLst>
           </p:cNvPr>
@@ -7163,7 +7163,7 @@
           <p:cNvPr id="22" name="">
             <a:extLst xmlns:a="http://schemas.openxmlformats.org/drawingml/2006/main">
               <a:ext uri="{FF2B5EF4-FFF2-40B4-BE49-F238E27FC236}">
-                <a16:creationId xmlns:a16="http://schemas.microsoft.com/office/drawing/2014/main" id="{3964E977-104A-4301-816E-AD54FEF8EB77}"/>
+                <a16:creationId xmlns:a16="http://schemas.microsoft.com/office/drawing/2014/main" id="{7366E7A9-8075-4B96-9808-AD09B847B6A1}"/>
               </a:ext>
             </a:extLst>
           </p:cNvPr>
@@ -7243,7 +7243,7 @@
           <p:cNvPr id="23" name="">
             <a:extLst xmlns:a="http://schemas.openxmlformats.org/drawingml/2006/main">
               <a:ext uri="{FF2B5EF4-FFF2-40B4-BE49-F238E27FC236}">
-                <a16:creationId xmlns:a16="http://schemas.microsoft.com/office/drawing/2014/main" id="{0C499880-1767-485B-ABCC-A76410C920D9}"/>
+                <a16:creationId xmlns:a16="http://schemas.microsoft.com/office/drawing/2014/main" id="{41F2C719-0F46-42F5-8C12-6E112FF8BD20}"/>
               </a:ext>
             </a:extLst>
           </p:cNvPr>
@@ -7273,7 +7273,7 @@
           <p:cNvPr id="24" name="">
             <a:extLst xmlns:a="http://schemas.openxmlformats.org/drawingml/2006/main">
               <a:ext uri="{FF2B5EF4-FFF2-40B4-BE49-F238E27FC236}">
-                <a16:creationId xmlns:a16="http://schemas.microsoft.com/office/drawing/2014/main" id="{25E30DBB-C640-4E2B-A249-31DB3E55F7B1}"/>
+                <a16:creationId xmlns:a16="http://schemas.microsoft.com/office/drawing/2014/main" id="{439BCED3-DD3D-4346-8616-026DC9F79059}"/>
               </a:ext>
             </a:extLst>
           </p:cNvPr>
@@ -7307,7 +7307,7 @@
           <p:cNvPr id="25" name="">
             <a:extLst xmlns:a="http://schemas.openxmlformats.org/drawingml/2006/main">
               <a:ext uri="{FF2B5EF4-FFF2-40B4-BE49-F238E27FC236}">
-                <a16:creationId xmlns:a16="http://schemas.microsoft.com/office/drawing/2014/main" id="{1287968D-C02D-4672-8563-BBBC8951EA11}"/>
+                <a16:creationId xmlns:a16="http://schemas.microsoft.com/office/drawing/2014/main" id="{5912F677-CC23-4F59-ABA7-24F614CAA9CF}"/>
               </a:ext>
             </a:extLst>
           </p:cNvPr>
@@ -7366,7 +7366,7 @@
           <p:cNvPr id="26" name="">
             <a:extLst xmlns:a="http://schemas.openxmlformats.org/drawingml/2006/main">
               <a:ext uri="{FF2B5EF4-FFF2-40B4-BE49-F238E27FC236}">
-                <a16:creationId xmlns:a16="http://schemas.microsoft.com/office/drawing/2014/main" id="{2DA57440-F305-421A-ADAB-080C8DB961D4}"/>
+                <a16:creationId xmlns:a16="http://schemas.microsoft.com/office/drawing/2014/main" id="{747CC54E-BD0D-42FD-A8C8-93A5E754B97F}"/>
               </a:ext>
             </a:extLst>
           </p:cNvPr>
@@ -7423,7 +7423,7 @@
           <p:cNvPr id="27" name="">
             <a:extLst xmlns:a="http://schemas.openxmlformats.org/drawingml/2006/main">
               <a:ext uri="{FF2B5EF4-FFF2-40B4-BE49-F238E27FC236}">
-                <a16:creationId xmlns:a16="http://schemas.microsoft.com/office/drawing/2014/main" id="{53AB58AF-4161-436C-B4E6-1EE676142165}"/>
+                <a16:creationId xmlns:a16="http://schemas.microsoft.com/office/drawing/2014/main" id="{39549402-B6AE-4F26-BEE9-90E9AAC32D5E}"/>
               </a:ext>
             </a:extLst>
           </p:cNvPr>
@@ -7503,7 +7503,7 @@
           <p:cNvPr id="28" name="">
             <a:extLst xmlns:a="http://schemas.openxmlformats.org/drawingml/2006/main">
               <a:ext uri="{FF2B5EF4-FFF2-40B4-BE49-F238E27FC236}">
-                <a16:creationId xmlns:a16="http://schemas.microsoft.com/office/drawing/2014/main" id="{F7A4AE6B-2C78-4EE5-9BE1-070ADD2B4870}"/>
+                <a16:creationId xmlns:a16="http://schemas.microsoft.com/office/drawing/2014/main" id="{BF8E8DFB-758A-47E9-A72A-3F82C8343455}"/>
               </a:ext>
             </a:extLst>
           </p:cNvPr>
@@ -7560,7 +7560,7 @@
           <p:cNvPr id="29" name="">
             <a:extLst xmlns:a="http://schemas.openxmlformats.org/drawingml/2006/main">
               <a:ext uri="{FF2B5EF4-FFF2-40B4-BE49-F238E27FC236}">
-                <a16:creationId xmlns:a16="http://schemas.microsoft.com/office/drawing/2014/main" id="{F26D5A39-3755-4A37-B00E-482DC4AD5FBF}"/>
+                <a16:creationId xmlns:a16="http://schemas.microsoft.com/office/drawing/2014/main" id="{DF08CE84-6CB7-4EF3-8624-54AEE3CA15AE}"/>
               </a:ext>
             </a:extLst>
           </p:cNvPr>
@@ -7617,7 +7617,7 @@
           <p:cNvPr id="30" name="">
             <a:extLst xmlns:a="http://schemas.openxmlformats.org/drawingml/2006/main">
               <a:ext uri="{FF2B5EF4-FFF2-40B4-BE49-F238E27FC236}">
-                <a16:creationId xmlns:a16="http://schemas.microsoft.com/office/drawing/2014/main" id="{23186C1A-029F-4DFA-BBEC-3CB8A517F782}"/>
+                <a16:creationId xmlns:a16="http://schemas.microsoft.com/office/drawing/2014/main" id="{87ED2AE9-3936-4A93-AC02-C55575FD7996}"/>
               </a:ext>
             </a:extLst>
           </p:cNvPr>
@@ -7674,7 +7674,7 @@
           <p:cNvPr id="31" name="">
             <a:extLst xmlns:a="http://schemas.openxmlformats.org/drawingml/2006/main">
               <a:ext uri="{FF2B5EF4-FFF2-40B4-BE49-F238E27FC236}">
-                <a16:creationId xmlns:a16="http://schemas.microsoft.com/office/drawing/2014/main" id="{9313D2AF-89E6-4180-9E5F-2C63FAF01886}"/>
+                <a16:creationId xmlns:a16="http://schemas.microsoft.com/office/drawing/2014/main" id="{9E78895E-02C0-4FEA-9656-32FB5E85ED12}"/>
               </a:ext>
             </a:extLst>
           </p:cNvPr>
@@ -7731,7 +7731,7 @@
           <p:cNvPr id="32" name="">
             <a:extLst xmlns:a="http://schemas.openxmlformats.org/drawingml/2006/main">
               <a:ext uri="{FF2B5EF4-FFF2-40B4-BE49-F238E27FC236}">
-                <a16:creationId xmlns:a16="http://schemas.microsoft.com/office/drawing/2014/main" id="{24FEAEA7-6961-461D-96E5-85E881F7353F}"/>
+                <a16:creationId xmlns:a16="http://schemas.microsoft.com/office/drawing/2014/main" id="{DE434193-8C21-40FF-AB23-1D1DBB68CF0C}"/>
               </a:ext>
             </a:extLst>
           </p:cNvPr>
@@ -7788,7 +7788,7 @@
           <p:cNvPr id="33" name="">
             <a:extLst xmlns:a="http://schemas.openxmlformats.org/drawingml/2006/main">
               <a:ext uri="{FF2B5EF4-FFF2-40B4-BE49-F238E27FC236}">
-                <a16:creationId xmlns:a16="http://schemas.microsoft.com/office/drawing/2014/main" id="{14306A9C-54B3-49B6-9D00-C429870DC00D}"/>
+                <a16:creationId xmlns:a16="http://schemas.microsoft.com/office/drawing/2014/main" id="{630C4598-DF99-4913-BB10-ADD980182E3C}"/>
               </a:ext>
             </a:extLst>
           </p:cNvPr>
@@ -7845,7 +7845,7 @@
           <p:cNvPr id="34" name="">
             <a:extLst xmlns:a="http://schemas.openxmlformats.org/drawingml/2006/main">
               <a:ext uri="{FF2B5EF4-FFF2-40B4-BE49-F238E27FC236}">
-                <a16:creationId xmlns:a16="http://schemas.microsoft.com/office/drawing/2014/main" id="{DB3A971C-0782-4F0B-A9C8-76F145BF947D}"/>
+                <a16:creationId xmlns:a16="http://schemas.microsoft.com/office/drawing/2014/main" id="{CB9CF893-E0F3-41B7-885F-927BF66645D2}"/>
               </a:ext>
             </a:extLst>
           </p:cNvPr>
@@ -7902,7 +7902,7 @@
           <p:cNvPr id="35" name="">
             <a:extLst xmlns:a="http://schemas.openxmlformats.org/drawingml/2006/main">
               <a:ext uri="{FF2B5EF4-FFF2-40B4-BE49-F238E27FC236}">
-                <a16:creationId xmlns:a16="http://schemas.microsoft.com/office/drawing/2014/main" id="{39F7A257-FE12-4BB2-9F20-A592D8B2F4D5}"/>
+                <a16:creationId xmlns:a16="http://schemas.microsoft.com/office/drawing/2014/main" id="{8AB68579-B53F-41C9-83FE-03B702842064}"/>
               </a:ext>
             </a:extLst>
           </p:cNvPr>
@@ -7959,7 +7959,7 @@
           <p:cNvPr id="36" name="">
             <a:extLst xmlns:a="http://schemas.openxmlformats.org/drawingml/2006/main">
               <a:ext uri="{FF2B5EF4-FFF2-40B4-BE49-F238E27FC236}">
-                <a16:creationId xmlns:a16="http://schemas.microsoft.com/office/drawing/2014/main" id="{5D7D2EEF-E1E0-4E5F-BEC7-8F6E7C0044F0}"/>
+                <a16:creationId xmlns:a16="http://schemas.microsoft.com/office/drawing/2014/main" id="{74A8CFF6-27A4-45FB-A7F0-EC655A2EF019}"/>
               </a:ext>
             </a:extLst>
           </p:cNvPr>
@@ -8016,7 +8016,7 @@
           <p:cNvPr id="37" name="">
             <a:extLst xmlns:a="http://schemas.openxmlformats.org/drawingml/2006/main">
               <a:ext uri="{FF2B5EF4-FFF2-40B4-BE49-F238E27FC236}">
-                <a16:creationId xmlns:a16="http://schemas.microsoft.com/office/drawing/2014/main" id="{31406D97-2579-48FC-AF0B-60852D1BDCDD}"/>
+                <a16:creationId xmlns:a16="http://schemas.microsoft.com/office/drawing/2014/main" id="{1B524BD5-8B14-4625-8DC9-345BA6BDF439}"/>
               </a:ext>
             </a:extLst>
           </p:cNvPr>
@@ -8075,7 +8075,7 @@
           <p:cNvPr id="38" name="">
             <a:extLst xmlns:a="http://schemas.openxmlformats.org/drawingml/2006/main">
               <a:ext uri="{FF2B5EF4-FFF2-40B4-BE49-F238E27FC236}">
-                <a16:creationId xmlns:a16="http://schemas.microsoft.com/office/drawing/2014/main" id="{6F57B9D9-CF00-42E7-B7B8-2DB688FC85DC}"/>
+                <a16:creationId xmlns:a16="http://schemas.microsoft.com/office/drawing/2014/main" id="{2FF958AE-4636-4A5E-B8FA-9B035F38BC4F}"/>
               </a:ext>
             </a:extLst>
           </p:cNvPr>
@@ -8105,7 +8105,7 @@
           <p:cNvPr id="39" name="">
             <a:extLst xmlns:a="http://schemas.openxmlformats.org/drawingml/2006/main">
               <a:ext uri="{FF2B5EF4-FFF2-40B4-BE49-F238E27FC236}">
-                <a16:creationId xmlns:a16="http://schemas.microsoft.com/office/drawing/2014/main" id="{2FA3FBF0-7C57-4EFB-9719-7BFA556406DD}"/>
+                <a16:creationId xmlns:a16="http://schemas.microsoft.com/office/drawing/2014/main" id="{A72C23B3-4C4E-4FB1-99BA-B621A282405D}"/>
               </a:ext>
             </a:extLst>
           </p:cNvPr>
@@ -8162,7 +8162,7 @@
           <p:cNvPr id="40" name="">
             <a:extLst xmlns:a="http://schemas.openxmlformats.org/drawingml/2006/main">
               <a:ext uri="{FF2B5EF4-FFF2-40B4-BE49-F238E27FC236}">
-                <a16:creationId xmlns:a16="http://schemas.microsoft.com/office/drawing/2014/main" id="{2CE7B3BF-FA1C-43C4-AE2C-E50059771275}"/>
+                <a16:creationId xmlns:a16="http://schemas.microsoft.com/office/drawing/2014/main" id="{2509545E-9073-44F4-8238-FBF33B294DB0}"/>
               </a:ext>
             </a:extLst>
           </p:cNvPr>
@@ -8217,7 +8217,7 @@
     </p:spTree>
     <p:extLst>
       <p:ext uri="{BB962C8B-B14F-4D97-AF65-F5344CB8AC3E}">
-        <p14:creationId xmlns:p14="http://schemas.microsoft.com/office/powerpoint/2010/main" val="2091270053"/>
+        <p14:creationId xmlns:p14="http://schemas.microsoft.com/office/powerpoint/2010/main" val="1537684352"/>
       </p:ext>
     </p:extLst>
   </p:cSld>
@@ -8248,7 +8248,7 @@
           <p:cNvPr id="34" name="">
             <a:extLst xmlns:a="http://schemas.openxmlformats.org/drawingml/2006/main">
               <a:ext uri="{FF2B5EF4-FFF2-40B4-BE49-F238E27FC236}">
-                <a16:creationId xmlns:a16="http://schemas.microsoft.com/office/drawing/2014/main" id="{24EB4565-FAC6-4686-ACDB-B5ED7FADC1D1}"/>
+                <a16:creationId xmlns:a16="http://schemas.microsoft.com/office/drawing/2014/main" id="{BD2ADA27-FB29-4C16-84AD-9E77D6C5C4F8}"/>
               </a:ext>
             </a:extLst>
           </p:cNvPr>
@@ -8305,7 +8305,7 @@
           <p:cNvPr id="2" name="">
             <a:extLst xmlns:a="http://schemas.openxmlformats.org/drawingml/2006/main">
               <a:ext uri="{FF2B5EF4-FFF2-40B4-BE49-F238E27FC236}">
-                <a16:creationId xmlns:a16="http://schemas.microsoft.com/office/drawing/2014/main" id="{2CC651CB-AF86-4021-B00D-CE64C1366A62}"/>
+                <a16:creationId xmlns:a16="http://schemas.microsoft.com/office/drawing/2014/main" id="{A7EC5DFD-69ED-46DB-9E43-1A37452AA1B2}"/>
               </a:ext>
             </a:extLst>
           </p:cNvPr>
@@ -8335,7 +8335,7 @@
           <p:cNvPr id="3" name="">
             <a:extLst xmlns:a="http://schemas.openxmlformats.org/drawingml/2006/main">
               <a:ext uri="{FF2B5EF4-FFF2-40B4-BE49-F238E27FC236}">
-                <a16:creationId xmlns:a16="http://schemas.microsoft.com/office/drawing/2014/main" id="{DEC74F21-F065-4A2A-9DBD-B678CF7DED95}"/>
+                <a16:creationId xmlns:a16="http://schemas.microsoft.com/office/drawing/2014/main" id="{43EF02E1-94B1-4289-A838-C62C9329C0D6}"/>
               </a:ext>
             </a:extLst>
           </p:cNvPr>
@@ -8392,7 +8392,7 @@
           <p:cNvPr id="4" name="">
             <a:extLst xmlns:a="http://schemas.openxmlformats.org/drawingml/2006/main">
               <a:ext uri="{FF2B5EF4-FFF2-40B4-BE49-F238E27FC236}">
-                <a16:creationId xmlns:a16="http://schemas.microsoft.com/office/drawing/2014/main" id="{4D1FF7B8-490A-4A82-ACCE-69227CA3436A}"/>
+                <a16:creationId xmlns:a16="http://schemas.microsoft.com/office/drawing/2014/main" id="{273B61BB-9673-4A2A-A991-BAC2664B0810}"/>
               </a:ext>
             </a:extLst>
           </p:cNvPr>
@@ -8426,7 +8426,7 @@
           <p:cNvPr id="5" name="">
             <a:extLst xmlns:a="http://schemas.openxmlformats.org/drawingml/2006/main">
               <a:ext uri="{FF2B5EF4-FFF2-40B4-BE49-F238E27FC236}">
-                <a16:creationId xmlns:a16="http://schemas.microsoft.com/office/drawing/2014/main" id="{B0EDB4B8-CECA-4371-828D-CED32C44674E}"/>
+                <a16:creationId xmlns:a16="http://schemas.microsoft.com/office/drawing/2014/main" id="{DF0DE74F-2B35-4A13-85DA-5BEEB127DDBE}"/>
               </a:ext>
             </a:extLst>
           </p:cNvPr>
@@ -8483,7 +8483,7 @@
           <p:cNvPr id="6" name="">
             <a:extLst xmlns:a="http://schemas.openxmlformats.org/drawingml/2006/main">
               <a:ext uri="{FF2B5EF4-FFF2-40B4-BE49-F238E27FC236}">
-                <a16:creationId xmlns:a16="http://schemas.microsoft.com/office/drawing/2014/main" id="{7A052A7B-A0A2-4840-B550-4CC5555C9659}"/>
+                <a16:creationId xmlns:a16="http://schemas.microsoft.com/office/drawing/2014/main" id="{852831B5-CCC8-4A35-8601-EE861D2D844E}"/>
               </a:ext>
             </a:extLst>
           </p:cNvPr>
@@ -8540,7 +8540,7 @@
           <p:cNvPr id="7" name="">
             <a:extLst xmlns:a="http://schemas.openxmlformats.org/drawingml/2006/main">
               <a:ext uri="{FF2B5EF4-FFF2-40B4-BE49-F238E27FC236}">
-                <a16:creationId xmlns:a16="http://schemas.microsoft.com/office/drawing/2014/main" id="{2A1DFA38-93C9-4004-B021-AA1D051A990C}"/>
+                <a16:creationId xmlns:a16="http://schemas.microsoft.com/office/drawing/2014/main" id="{95D3C83F-77B1-4237-9DFD-737922AD1352}"/>
               </a:ext>
             </a:extLst>
           </p:cNvPr>
@@ -8570,7 +8570,7 @@
           <p:cNvPr id="8" name="">
             <a:extLst xmlns:a="http://schemas.openxmlformats.org/drawingml/2006/main">
               <a:ext uri="{FF2B5EF4-FFF2-40B4-BE49-F238E27FC236}">
-                <a16:creationId xmlns:a16="http://schemas.microsoft.com/office/drawing/2014/main" id="{D0477D15-BA6A-41B4-8E59-9AEC958E42D0}"/>
+                <a16:creationId xmlns:a16="http://schemas.microsoft.com/office/drawing/2014/main" id="{55E8C6AD-F0FA-48D8-ADB1-058AC52D4C39}"/>
               </a:ext>
             </a:extLst>
           </p:cNvPr>
@@ -8604,7 +8604,7 @@
           <p:cNvPr id="9" name="">
             <a:extLst xmlns:a="http://schemas.openxmlformats.org/drawingml/2006/main">
               <a:ext uri="{FF2B5EF4-FFF2-40B4-BE49-F238E27FC236}">
-                <a16:creationId xmlns:a16="http://schemas.microsoft.com/office/drawing/2014/main" id="{C3D59CB5-14D2-4F00-8259-D64F203C318D}"/>
+                <a16:creationId xmlns:a16="http://schemas.microsoft.com/office/drawing/2014/main" id="{1F760D00-6420-46ED-A028-68D8CAE78C52}"/>
               </a:ext>
             </a:extLst>
           </p:cNvPr>
@@ -8661,7 +8661,7 @@
           <p:cNvPr id="10" name="">
             <a:extLst xmlns:a="http://schemas.openxmlformats.org/drawingml/2006/main">
               <a:ext uri="{FF2B5EF4-FFF2-40B4-BE49-F238E27FC236}">
-                <a16:creationId xmlns:a16="http://schemas.microsoft.com/office/drawing/2014/main" id="{A0CD84E5-1E3D-4A68-AEFC-9F292C8330AB}"/>
+                <a16:creationId xmlns:a16="http://schemas.microsoft.com/office/drawing/2014/main" id="{5E4C2363-A260-4472-892C-DC5C61295E8A}"/>
               </a:ext>
             </a:extLst>
           </p:cNvPr>
@@ -8718,7 +8718,7 @@
           <p:cNvPr id="11" name="">
             <a:extLst xmlns:a="http://schemas.openxmlformats.org/drawingml/2006/main">
               <a:ext uri="{FF2B5EF4-FFF2-40B4-BE49-F238E27FC236}">
-                <a16:creationId xmlns:a16="http://schemas.microsoft.com/office/drawing/2014/main" id="{35F5730F-6B47-463F-A42A-84EAC0EBD3F5}"/>
+                <a16:creationId xmlns:a16="http://schemas.microsoft.com/office/drawing/2014/main" id="{B6E02500-914F-4C78-8DC3-EFFEA60F80DA}"/>
               </a:ext>
             </a:extLst>
           </p:cNvPr>
@@ -8748,7 +8748,7 @@
           <p:cNvPr id="12" name="">
             <a:extLst xmlns:a="http://schemas.openxmlformats.org/drawingml/2006/main">
               <a:ext uri="{FF2B5EF4-FFF2-40B4-BE49-F238E27FC236}">
-                <a16:creationId xmlns:a16="http://schemas.microsoft.com/office/drawing/2014/main" id="{1F282230-B2D1-4A46-AF7A-419115615063}"/>
+                <a16:creationId xmlns:a16="http://schemas.microsoft.com/office/drawing/2014/main" id="{8D59DE0E-8313-4C26-9E35-4D63D26A0B7F}"/>
               </a:ext>
             </a:extLst>
           </p:cNvPr>
@@ -8782,7 +8782,7 @@
           <p:cNvPr id="13" name="">
             <a:extLst xmlns:a="http://schemas.openxmlformats.org/drawingml/2006/main">
               <a:ext uri="{FF2B5EF4-FFF2-40B4-BE49-F238E27FC236}">
-                <a16:creationId xmlns:a16="http://schemas.microsoft.com/office/drawing/2014/main" id="{9331E71F-49DD-477E-95E3-C9648E06027F}"/>
+                <a16:creationId xmlns:a16="http://schemas.microsoft.com/office/drawing/2014/main" id="{2E680FD8-A8A5-4F96-A9A8-1AF773E9891B}"/>
               </a:ext>
             </a:extLst>
           </p:cNvPr>
@@ -8839,7 +8839,7 @@
           <p:cNvPr id="14" name="">
             <a:extLst xmlns:a="http://schemas.openxmlformats.org/drawingml/2006/main">
               <a:ext uri="{FF2B5EF4-FFF2-40B4-BE49-F238E27FC236}">
-                <a16:creationId xmlns:a16="http://schemas.microsoft.com/office/drawing/2014/main" id="{96009E5E-5DC9-4011-AE19-83E6CEA2CB22}"/>
+                <a16:creationId xmlns:a16="http://schemas.microsoft.com/office/drawing/2014/main" id="{C310E80D-AAA3-46EA-90B9-294E3C3E5C92}"/>
               </a:ext>
             </a:extLst>
           </p:cNvPr>
@@ -8896,7 +8896,7 @@
           <p:cNvPr id="15" name="">
             <a:extLst xmlns:a="http://schemas.openxmlformats.org/drawingml/2006/main">
               <a:ext uri="{FF2B5EF4-FFF2-40B4-BE49-F238E27FC236}">
-                <a16:creationId xmlns:a16="http://schemas.microsoft.com/office/drawing/2014/main" id="{58B0A997-6E75-41D8-8519-18D7A062F108}"/>
+                <a16:creationId xmlns:a16="http://schemas.microsoft.com/office/drawing/2014/main" id="{319365C7-CF14-488F-A4DC-F348099B88BA}"/>
               </a:ext>
             </a:extLst>
           </p:cNvPr>
@@ -8926,7 +8926,7 @@
           <p:cNvPr id="16" name="">
             <a:extLst xmlns:a="http://schemas.openxmlformats.org/drawingml/2006/main">
               <a:ext uri="{FF2B5EF4-FFF2-40B4-BE49-F238E27FC236}">
-                <a16:creationId xmlns:a16="http://schemas.microsoft.com/office/drawing/2014/main" id="{BF72C4D6-DCD9-4D98-A045-3E97DB455D05}"/>
+                <a16:creationId xmlns:a16="http://schemas.microsoft.com/office/drawing/2014/main" id="{1C28704E-053B-4D4A-AF21-7F3F35D82B00}"/>
               </a:ext>
             </a:extLst>
           </p:cNvPr>
@@ -8960,7 +8960,7 @@
           <p:cNvPr id="17" name="">
             <a:extLst xmlns:a="http://schemas.openxmlformats.org/drawingml/2006/main">
               <a:ext uri="{FF2B5EF4-FFF2-40B4-BE49-F238E27FC236}">
-                <a16:creationId xmlns:a16="http://schemas.microsoft.com/office/drawing/2014/main" id="{C42024E9-9690-44C4-8954-2F0178752661}"/>
+                <a16:creationId xmlns:a16="http://schemas.microsoft.com/office/drawing/2014/main" id="{46A57AF3-0F82-4DAB-83BB-365402DFBFF3}"/>
               </a:ext>
             </a:extLst>
           </p:cNvPr>
@@ -9017,7 +9017,7 @@
           <p:cNvPr id="18" name="">
             <a:extLst xmlns:a="http://schemas.openxmlformats.org/drawingml/2006/main">
               <a:ext uri="{FF2B5EF4-FFF2-40B4-BE49-F238E27FC236}">
-                <a16:creationId xmlns:a16="http://schemas.microsoft.com/office/drawing/2014/main" id="{790758E0-F026-4566-AC06-3CB1C927B27D}"/>
+                <a16:creationId xmlns:a16="http://schemas.microsoft.com/office/drawing/2014/main" id="{8F6540BB-6A48-492E-9D3A-7118056B54A6}"/>
               </a:ext>
             </a:extLst>
           </p:cNvPr>
@@ -9074,7 +9074,7 @@
           <p:cNvPr id="19" name="">
             <a:extLst xmlns:a="http://schemas.openxmlformats.org/drawingml/2006/main">
               <a:ext uri="{FF2B5EF4-FFF2-40B4-BE49-F238E27FC236}">
-                <a16:creationId xmlns:a16="http://schemas.microsoft.com/office/drawing/2014/main" id="{0E70FE2F-9B49-4D95-A8CD-8F43649FDC81}"/>
+                <a16:creationId xmlns:a16="http://schemas.microsoft.com/office/drawing/2014/main" id="{6ED04E8F-9BEC-42AE-83B7-FD0A7FD8AA04}"/>
               </a:ext>
             </a:extLst>
           </p:cNvPr>
@@ -9104,7 +9104,7 @@
           <p:cNvPr id="20" name="">
             <a:extLst xmlns:a="http://schemas.openxmlformats.org/drawingml/2006/main">
               <a:ext uri="{FF2B5EF4-FFF2-40B4-BE49-F238E27FC236}">
-                <a16:creationId xmlns:a16="http://schemas.microsoft.com/office/drawing/2014/main" id="{7F987C2E-4A9B-4656-807C-C45255E57D36}"/>
+                <a16:creationId xmlns:a16="http://schemas.microsoft.com/office/drawing/2014/main" id="{AC4D0AD7-DBCA-46D2-A31C-F1FE6C2D02E0}"/>
               </a:ext>
             </a:extLst>
           </p:cNvPr>
@@ -9138,7 +9138,7 @@
           <p:cNvPr id="21" name="">
             <a:extLst xmlns:a="http://schemas.openxmlformats.org/drawingml/2006/main">
               <a:ext uri="{FF2B5EF4-FFF2-40B4-BE49-F238E27FC236}">
-                <a16:creationId xmlns:a16="http://schemas.microsoft.com/office/drawing/2014/main" id="{A8AE702A-9D02-4C44-B854-6C96AE4A7F85}"/>
+                <a16:creationId xmlns:a16="http://schemas.microsoft.com/office/drawing/2014/main" id="{8371CEA6-72DA-41DD-8119-637DF62E8A9B}"/>
               </a:ext>
             </a:extLst>
           </p:cNvPr>
@@ -9195,7 +9195,7 @@
           <p:cNvPr id="22" name="">
             <a:extLst xmlns:a="http://schemas.openxmlformats.org/drawingml/2006/main">
               <a:ext uri="{FF2B5EF4-FFF2-40B4-BE49-F238E27FC236}">
-                <a16:creationId xmlns:a16="http://schemas.microsoft.com/office/drawing/2014/main" id="{CD68F6E1-35AE-4AAE-AAA9-F73FA3168CA7}"/>
+                <a16:creationId xmlns:a16="http://schemas.microsoft.com/office/drawing/2014/main" id="{170154D9-4529-4BA7-84FF-269DAF719F92}"/>
               </a:ext>
             </a:extLst>
           </p:cNvPr>
@@ -9252,7 +9252,7 @@
           <p:cNvPr id="23" name="">
             <a:extLst xmlns:a="http://schemas.openxmlformats.org/drawingml/2006/main">
               <a:ext uri="{FF2B5EF4-FFF2-40B4-BE49-F238E27FC236}">
-                <a16:creationId xmlns:a16="http://schemas.microsoft.com/office/drawing/2014/main" id="{9AAF6D2D-21D8-47BC-BD32-7B849CC10EAF}"/>
+                <a16:creationId xmlns:a16="http://schemas.microsoft.com/office/drawing/2014/main" id="{9A34A71B-0B1F-4833-8A81-8C122140781F}"/>
               </a:ext>
             </a:extLst>
           </p:cNvPr>
@@ -9282,7 +9282,7 @@
           <p:cNvPr id="24" name="">
             <a:extLst xmlns:a="http://schemas.openxmlformats.org/drawingml/2006/main">
               <a:ext uri="{FF2B5EF4-FFF2-40B4-BE49-F238E27FC236}">
-                <a16:creationId xmlns:a16="http://schemas.microsoft.com/office/drawing/2014/main" id="{84AF84A1-9A13-457E-9A44-5B81235B833F}"/>
+                <a16:creationId xmlns:a16="http://schemas.microsoft.com/office/drawing/2014/main" id="{BE06E048-70BE-419B-91B3-96B699F57A50}"/>
               </a:ext>
             </a:extLst>
           </p:cNvPr>
@@ -9316,7 +9316,7 @@
           <p:cNvPr id="25" name="">
             <a:extLst xmlns:a="http://schemas.openxmlformats.org/drawingml/2006/main">
               <a:ext uri="{FF2B5EF4-FFF2-40B4-BE49-F238E27FC236}">
-                <a16:creationId xmlns:a16="http://schemas.microsoft.com/office/drawing/2014/main" id="{AC21DD47-7968-4640-9CB1-FDF86EF68FE4}"/>
+                <a16:creationId xmlns:a16="http://schemas.microsoft.com/office/drawing/2014/main" id="{2F74D85C-2A36-4B17-AE98-319B8815FE05}"/>
               </a:ext>
             </a:extLst>
           </p:cNvPr>
@@ -9373,7 +9373,7 @@
           <p:cNvPr id="26" name="">
             <a:extLst xmlns:a="http://schemas.openxmlformats.org/drawingml/2006/main">
               <a:ext uri="{FF2B5EF4-FFF2-40B4-BE49-F238E27FC236}">
-                <a16:creationId xmlns:a16="http://schemas.microsoft.com/office/drawing/2014/main" id="{C105B213-BA05-493A-8491-EF59CE63E227}"/>
+                <a16:creationId xmlns:a16="http://schemas.microsoft.com/office/drawing/2014/main" id="{925BFC85-CCEF-4524-B32A-61C752CC7DB2}"/>
               </a:ext>
             </a:extLst>
           </p:cNvPr>
@@ -9430,7 +9430,7 @@
           <p:cNvPr id="27" name="">
             <a:extLst xmlns:a="http://schemas.openxmlformats.org/drawingml/2006/main">
               <a:ext uri="{FF2B5EF4-FFF2-40B4-BE49-F238E27FC236}">
-                <a16:creationId xmlns:a16="http://schemas.microsoft.com/office/drawing/2014/main" id="{C5BF0D9F-943A-4A0F-8033-66D8325C8028}"/>
+                <a16:creationId xmlns:a16="http://schemas.microsoft.com/office/drawing/2014/main" id="{B140680D-5AF4-4187-B6D9-6067B5E7C41A}"/>
               </a:ext>
             </a:extLst>
           </p:cNvPr>
@@ -9487,7 +9487,7 @@
           <p:cNvPr id="28" name="">
             <a:extLst xmlns:a="http://schemas.openxmlformats.org/drawingml/2006/main">
               <a:ext uri="{FF2B5EF4-FFF2-40B4-BE49-F238E27FC236}">
-                <a16:creationId xmlns:a16="http://schemas.microsoft.com/office/drawing/2014/main" id="{2DDFC25C-B8C0-48B1-BC33-B273915BABFF}"/>
+                <a16:creationId xmlns:a16="http://schemas.microsoft.com/office/drawing/2014/main" id="{A2491073-1741-417F-9C21-6158EB53326E}"/>
               </a:ext>
             </a:extLst>
           </p:cNvPr>
@@ -9544,7 +9544,7 @@
           <p:cNvPr id="29" name="">
             <a:extLst xmlns:a="http://schemas.openxmlformats.org/drawingml/2006/main">
               <a:ext uri="{FF2B5EF4-FFF2-40B4-BE49-F238E27FC236}">
-                <a16:creationId xmlns:a16="http://schemas.microsoft.com/office/drawing/2014/main" id="{A32ECBF4-CB92-40DA-AEAC-DD620243440A}"/>
+                <a16:creationId xmlns:a16="http://schemas.microsoft.com/office/drawing/2014/main" id="{286F5305-9A56-4E88-B0EB-61EDF562DFAC}"/>
               </a:ext>
             </a:extLst>
           </p:cNvPr>
@@ -9626,7 +9626,7 @@
           <p:cNvPr id="30" name="">
             <a:extLst xmlns:a="http://schemas.openxmlformats.org/drawingml/2006/main">
               <a:ext uri="{FF2B5EF4-FFF2-40B4-BE49-F238E27FC236}">
-                <a16:creationId xmlns:a16="http://schemas.microsoft.com/office/drawing/2014/main" id="{8E2D92D9-FB0C-4349-918B-FD4180794BD8}"/>
+                <a16:creationId xmlns:a16="http://schemas.microsoft.com/office/drawing/2014/main" id="{1AE87A4F-A122-42F9-854F-55E649E937C6}"/>
               </a:ext>
             </a:extLst>
           </p:cNvPr>
@@ -9685,7 +9685,7 @@
           <p:cNvPr id="31" name="">
             <a:extLst xmlns:a="http://schemas.openxmlformats.org/drawingml/2006/main">
               <a:ext uri="{FF2B5EF4-FFF2-40B4-BE49-F238E27FC236}">
-                <a16:creationId xmlns:a16="http://schemas.microsoft.com/office/drawing/2014/main" id="{D0FE8EC3-B56C-4B20-BF64-2E3177D6B0DE}"/>
+                <a16:creationId xmlns:a16="http://schemas.microsoft.com/office/drawing/2014/main" id="{11A2AC3A-EF6A-4BE3-A1AD-37F5CE293579}"/>
               </a:ext>
             </a:extLst>
           </p:cNvPr>
@@ -9715,7 +9715,7 @@
           <p:cNvPr id="32" name="">
             <a:extLst xmlns:a="http://schemas.openxmlformats.org/drawingml/2006/main">
               <a:ext uri="{FF2B5EF4-FFF2-40B4-BE49-F238E27FC236}">
-                <a16:creationId xmlns:a16="http://schemas.microsoft.com/office/drawing/2014/main" id="{BD239385-AEE5-4914-B457-2E5F951EEDDA}"/>
+                <a16:creationId xmlns:a16="http://schemas.microsoft.com/office/drawing/2014/main" id="{05F8BAD7-9D78-4B82-ADC4-AC561EEBB71B}"/>
               </a:ext>
             </a:extLst>
           </p:cNvPr>
@@ -9772,7 +9772,7 @@
           <p:cNvPr id="33" name="">
             <a:extLst xmlns:a="http://schemas.openxmlformats.org/drawingml/2006/main">
               <a:ext uri="{FF2B5EF4-FFF2-40B4-BE49-F238E27FC236}">
-                <a16:creationId xmlns:a16="http://schemas.microsoft.com/office/drawing/2014/main" id="{98C8044B-440C-465F-A94D-91F1A4124232}"/>
+                <a16:creationId xmlns:a16="http://schemas.microsoft.com/office/drawing/2014/main" id="{ECD32050-6EC6-4665-98CB-72D871387560}"/>
               </a:ext>
             </a:extLst>
           </p:cNvPr>
@@ -9827,7 +9827,7 @@
     </p:spTree>
     <p:extLst>
       <p:ext uri="{BB962C8B-B14F-4D97-AF65-F5344CB8AC3E}">
-        <p14:creationId xmlns:p14="http://schemas.microsoft.com/office/powerpoint/2010/main" val="88569819"/>
+        <p14:creationId xmlns:p14="http://schemas.microsoft.com/office/powerpoint/2010/main" val="133257666"/>
       </p:ext>
     </p:extLst>
   </p:cSld>
@@ -9858,7 +9858,7 @@
           <p:cNvPr id="10" name="">
             <a:extLst xmlns:a="http://schemas.openxmlformats.org/drawingml/2006/main">
               <a:ext uri="{FF2B5EF4-FFF2-40B4-BE49-F238E27FC236}">
-                <a16:creationId xmlns:a16="http://schemas.microsoft.com/office/drawing/2014/main" id="{D15D2189-2A10-4751-BA2C-FB9DD8ED7FEE}"/>
+                <a16:creationId xmlns:a16="http://schemas.microsoft.com/office/drawing/2014/main" id="{5D309EFE-7C74-4EFF-89D2-458C7AC3AAB7}"/>
               </a:ext>
             </a:extLst>
           </p:cNvPr>
@@ -9915,7 +9915,7 @@
           <p:cNvPr id="2" name="">
             <a:extLst xmlns:a="http://schemas.openxmlformats.org/drawingml/2006/main">
               <a:ext uri="{FF2B5EF4-FFF2-40B4-BE49-F238E27FC236}">
-                <a16:creationId xmlns:a16="http://schemas.microsoft.com/office/drawing/2014/main" id="{BF0F14AF-401D-46AB-AC4D-776FEE0F5DEC}"/>
+                <a16:creationId xmlns:a16="http://schemas.microsoft.com/office/drawing/2014/main" id="{D008638C-A517-4312-871B-C1D9ACF721A3}"/>
               </a:ext>
             </a:extLst>
           </p:cNvPr>
@@ -9945,7 +9945,7 @@
           <p:cNvPr id="3" name="">
             <a:extLst xmlns:a="http://schemas.openxmlformats.org/drawingml/2006/main">
               <a:ext uri="{FF2B5EF4-FFF2-40B4-BE49-F238E27FC236}">
-                <a16:creationId xmlns:a16="http://schemas.microsoft.com/office/drawing/2014/main" id="{31208246-A569-4022-B563-7B78399A9188}"/>
+                <a16:creationId xmlns:a16="http://schemas.microsoft.com/office/drawing/2014/main" id="{A26DB107-408D-41D3-967E-96EB4881BA78}"/>
               </a:ext>
             </a:extLst>
           </p:cNvPr>
@@ -10326,7 +10326,7 @@
           <p:cNvPr id="5" name="">
             <a:extLst xmlns:a="http://schemas.openxmlformats.org/drawingml/2006/main">
               <a:ext uri="{FF2B5EF4-FFF2-40B4-BE49-F238E27FC236}">
-                <a16:creationId xmlns:a16="http://schemas.microsoft.com/office/drawing/2014/main" id="{FE573F3E-1053-4B56-9E7A-C27D66D4130C}"/>
+                <a16:creationId xmlns:a16="http://schemas.microsoft.com/office/drawing/2014/main" id="{47878723-F60F-4BC1-879F-5DD1396C13A2}"/>
               </a:ext>
             </a:extLst>
           </p:cNvPr>
@@ -10385,7 +10385,7 @@
           <p:cNvPr id="6" name="">
             <a:extLst xmlns:a="http://schemas.openxmlformats.org/drawingml/2006/main">
               <a:ext uri="{FF2B5EF4-FFF2-40B4-BE49-F238E27FC236}">
-                <a16:creationId xmlns:a16="http://schemas.microsoft.com/office/drawing/2014/main" id="{890C21E2-83BA-4AED-B95F-F0ED78AC352D}"/>
+                <a16:creationId xmlns:a16="http://schemas.microsoft.com/office/drawing/2014/main" id="{B0C4B32B-56B4-4EBB-AFC4-81671FAFDCA3}"/>
               </a:ext>
             </a:extLst>
           </p:cNvPr>
@@ -10442,7 +10442,7 @@
           <p:cNvPr id="7" name="">
             <a:extLst xmlns:a="http://schemas.openxmlformats.org/drawingml/2006/main">
               <a:ext uri="{FF2B5EF4-FFF2-40B4-BE49-F238E27FC236}">
-                <a16:creationId xmlns:a16="http://schemas.microsoft.com/office/drawing/2014/main" id="{9C199986-0998-4DB0-90D7-5852ACD5855C}"/>
+                <a16:creationId xmlns:a16="http://schemas.microsoft.com/office/drawing/2014/main" id="{4ADB081E-3705-4768-9FD8-DBD4B8B0380D}"/>
               </a:ext>
             </a:extLst>
           </p:cNvPr>
@@ -10472,7 +10472,7 @@
           <p:cNvPr id="8" name="">
             <a:extLst xmlns:a="http://schemas.openxmlformats.org/drawingml/2006/main">
               <a:ext uri="{FF2B5EF4-FFF2-40B4-BE49-F238E27FC236}">
-                <a16:creationId xmlns:a16="http://schemas.microsoft.com/office/drawing/2014/main" id="{E625F907-D602-42DF-9604-3A760EB89153}"/>
+                <a16:creationId xmlns:a16="http://schemas.microsoft.com/office/drawing/2014/main" id="{581DB60F-2278-413A-9205-58DB26E479DE}"/>
               </a:ext>
             </a:extLst>
           </p:cNvPr>
@@ -10529,7 +10529,7 @@
           <p:cNvPr id="9" name="">
             <a:extLst xmlns:a="http://schemas.openxmlformats.org/drawingml/2006/main">
               <a:ext uri="{FF2B5EF4-FFF2-40B4-BE49-F238E27FC236}">
-                <a16:creationId xmlns:a16="http://schemas.microsoft.com/office/drawing/2014/main" id="{57770D63-67A3-45C1-A772-BB4341034A42}"/>
+                <a16:creationId xmlns:a16="http://schemas.microsoft.com/office/drawing/2014/main" id="{D6B5C358-DCEA-4D6A-804C-AB694C48ADF3}"/>
               </a:ext>
             </a:extLst>
           </p:cNvPr>
@@ -10584,7 +10584,7 @@
     </p:spTree>
     <p:extLst>
       <p:ext uri="{BB962C8B-B14F-4D97-AF65-F5344CB8AC3E}">
-        <p14:creationId xmlns:p14="http://schemas.microsoft.com/office/powerpoint/2010/main" val="496062152"/>
+        <p14:creationId xmlns:p14="http://schemas.microsoft.com/office/powerpoint/2010/main" val="1376774172"/>
       </p:ext>
     </p:extLst>
   </p:cSld>
@@ -10615,7 +10615,7 @@
           <p:cNvPr id="15" name="">
             <a:extLst xmlns:a="http://schemas.openxmlformats.org/drawingml/2006/main">
               <a:ext uri="{FF2B5EF4-FFF2-40B4-BE49-F238E27FC236}">
-                <a16:creationId xmlns:a16="http://schemas.microsoft.com/office/drawing/2014/main" id="{87963097-F069-43E7-B289-0E8A791F8523}"/>
+                <a16:creationId xmlns:a16="http://schemas.microsoft.com/office/drawing/2014/main" id="{0744B092-76AD-45F8-9E57-7442ACD38AF2}"/>
               </a:ext>
             </a:extLst>
           </p:cNvPr>
@@ -10672,7 +10672,7 @@
           <p:cNvPr id="2" name="">
             <a:extLst xmlns:a="http://schemas.openxmlformats.org/drawingml/2006/main">
               <a:ext uri="{FF2B5EF4-FFF2-40B4-BE49-F238E27FC236}">
-                <a16:creationId xmlns:a16="http://schemas.microsoft.com/office/drawing/2014/main" id="{A1590EF7-5A82-4DCE-BEC6-27E51CAE5CE4}"/>
+                <a16:creationId xmlns:a16="http://schemas.microsoft.com/office/drawing/2014/main" id="{20FD7780-FA2D-4674-A8DF-490C2AC1FA1A}"/>
               </a:ext>
             </a:extLst>
           </p:cNvPr>
@@ -10702,7 +10702,7 @@
           <p:cNvPr id="3" name="">
             <a:extLst xmlns:a="http://schemas.openxmlformats.org/drawingml/2006/main">
               <a:ext uri="{FF2B5EF4-FFF2-40B4-BE49-F238E27FC236}">
-                <a16:creationId xmlns:a16="http://schemas.microsoft.com/office/drawing/2014/main" id="{A3F7F02A-0313-4A46-A656-2AB43DAFEA33}"/>
+                <a16:creationId xmlns:a16="http://schemas.microsoft.com/office/drawing/2014/main" id="{409CC97B-3C93-4A95-B92D-130E3726C4AB}"/>
               </a:ext>
             </a:extLst>
           </p:cNvPr>
@@ -10766,7 +10766,7 @@
         </p:xfrm>
         <a:graphic xmlns:a="http://schemas.openxmlformats.org/drawingml/2006/main">
           <a:graphicData uri="http://schemas.openxmlformats.org/drawingml/2006/chart">
-            <c:chart xmlns:r="http://schemas.openxmlformats.org/officeDocument/2006/relationships" xmlns:c="http://schemas.openxmlformats.org/drawingml/2006/chart" r:id="Rfc406e668d9e41ef"/>
+            <c:chart xmlns:r="http://schemas.openxmlformats.org/officeDocument/2006/relationships" xmlns:c="http://schemas.openxmlformats.org/drawingml/2006/chart" r:id="Rd17be0c04ab44701"/>
           </a:graphicData>
         </a:graphic>
       </p:graphicFrame>
@@ -10775,7 +10775,7 @@
           <p:cNvPr id="5" name="">
             <a:extLst xmlns:a="http://schemas.openxmlformats.org/drawingml/2006/main">
               <a:ext uri="{FF2B5EF4-FFF2-40B4-BE49-F238E27FC236}">
-                <a16:creationId xmlns:a16="http://schemas.microsoft.com/office/drawing/2014/main" id="{E4E04766-4350-4C8D-80C5-B4D1DADE91FB}"/>
+                <a16:creationId xmlns:a16="http://schemas.microsoft.com/office/drawing/2014/main" id="{6E9E7E06-BFA1-4F1D-AAC6-287DF2507A48}"/>
               </a:ext>
             </a:extLst>
           </p:cNvPr>
@@ -10832,7 +10832,7 @@
           <p:cNvPr id="6" name="">
             <a:extLst xmlns:a="http://schemas.openxmlformats.org/drawingml/2006/main">
               <a:ext uri="{FF2B5EF4-FFF2-40B4-BE49-F238E27FC236}">
-                <a16:creationId xmlns:a16="http://schemas.microsoft.com/office/drawing/2014/main" id="{ABCA0B93-A59B-4229-B597-DE4541BE5480}"/>
+                <a16:creationId xmlns:a16="http://schemas.microsoft.com/office/drawing/2014/main" id="{D6A9F143-EBD1-4BCB-AAC3-AE3DC24099DC}"/>
               </a:ext>
             </a:extLst>
           </p:cNvPr>
@@ -10889,7 +10889,7 @@
           <p:cNvPr id="7" name="">
             <a:extLst xmlns:a="http://schemas.openxmlformats.org/drawingml/2006/main">
               <a:ext uri="{FF2B5EF4-FFF2-40B4-BE49-F238E27FC236}">
-                <a16:creationId xmlns:a16="http://schemas.microsoft.com/office/drawing/2014/main" id="{504480D1-90BD-4DD8-B05D-663AFB444562}"/>
+                <a16:creationId xmlns:a16="http://schemas.microsoft.com/office/drawing/2014/main" id="{9E23CC42-8575-4463-AA1F-3F5BF3D2BBB0}"/>
               </a:ext>
             </a:extLst>
           </p:cNvPr>
@@ -10946,7 +10946,7 @@
           <p:cNvPr id="8" name="">
             <a:extLst xmlns:a="http://schemas.openxmlformats.org/drawingml/2006/main">
               <a:ext uri="{FF2B5EF4-FFF2-40B4-BE49-F238E27FC236}">
-                <a16:creationId xmlns:a16="http://schemas.microsoft.com/office/drawing/2014/main" id="{9E045FA4-4093-4D09-81A1-81C00B4E3A72}"/>
+                <a16:creationId xmlns:a16="http://schemas.microsoft.com/office/drawing/2014/main" id="{9BD45FDF-E9EB-4BC6-AFF1-D452BD46D3B4}"/>
               </a:ext>
             </a:extLst>
           </p:cNvPr>
@@ -11003,7 +11003,7 @@
           <p:cNvPr id="9" name="">
             <a:extLst xmlns:a="http://schemas.openxmlformats.org/drawingml/2006/main">
               <a:ext uri="{FF2B5EF4-FFF2-40B4-BE49-F238E27FC236}">
-                <a16:creationId xmlns:a16="http://schemas.microsoft.com/office/drawing/2014/main" id="{82DFE768-FB30-446E-A6B3-C487015E1FF7}"/>
+                <a16:creationId xmlns:a16="http://schemas.microsoft.com/office/drawing/2014/main" id="{5D4AC398-E8CC-47DC-A716-7386AB970565}"/>
               </a:ext>
             </a:extLst>
           </p:cNvPr>
@@ -11060,7 +11060,7 @@
           <p:cNvPr id="10" name="">
             <a:extLst xmlns:a="http://schemas.openxmlformats.org/drawingml/2006/main">
               <a:ext uri="{FF2B5EF4-FFF2-40B4-BE49-F238E27FC236}">
-                <a16:creationId xmlns:a16="http://schemas.microsoft.com/office/drawing/2014/main" id="{B0FAD67C-B939-4335-8BFB-38957243875B}"/>
+                <a16:creationId xmlns:a16="http://schemas.microsoft.com/office/drawing/2014/main" id="{E1B74901-199B-45FE-B281-E7FD00778B7B}"/>
               </a:ext>
             </a:extLst>
           </p:cNvPr>
@@ -11119,7 +11119,7 @@
           <p:cNvPr id="11" name="">
             <a:extLst xmlns:a="http://schemas.openxmlformats.org/drawingml/2006/main">
               <a:ext uri="{FF2B5EF4-FFF2-40B4-BE49-F238E27FC236}">
-                <a16:creationId xmlns:a16="http://schemas.microsoft.com/office/drawing/2014/main" id="{DBF7962B-FC1E-43B9-B71D-A230AA3D8A81}"/>
+                <a16:creationId xmlns:a16="http://schemas.microsoft.com/office/drawing/2014/main" id="{7E2C074C-CF09-470B-8A45-BAE736B15E8A}"/>
               </a:ext>
             </a:extLst>
           </p:cNvPr>
@@ -11178,7 +11178,7 @@
           <p:cNvPr id="12" name="">
             <a:extLst xmlns:a="http://schemas.openxmlformats.org/drawingml/2006/main">
               <a:ext uri="{FF2B5EF4-FFF2-40B4-BE49-F238E27FC236}">
-                <a16:creationId xmlns:a16="http://schemas.microsoft.com/office/drawing/2014/main" id="{B7B2B326-68FC-4E57-AE6F-998DBDE0B8E5}"/>
+                <a16:creationId xmlns:a16="http://schemas.microsoft.com/office/drawing/2014/main" id="{5873C232-E21E-432D-A2ED-22BD76E2BA4E}"/>
               </a:ext>
             </a:extLst>
           </p:cNvPr>
@@ -11208,7 +11208,7 @@
           <p:cNvPr id="13" name="">
             <a:extLst xmlns:a="http://schemas.openxmlformats.org/drawingml/2006/main">
               <a:ext uri="{FF2B5EF4-FFF2-40B4-BE49-F238E27FC236}">
-                <a16:creationId xmlns:a16="http://schemas.microsoft.com/office/drawing/2014/main" id="{CCC57AC9-7403-4427-97FB-DF1E9DD1C1F3}"/>
+                <a16:creationId xmlns:a16="http://schemas.microsoft.com/office/drawing/2014/main" id="{EEBF14C4-0C7A-4A49-87C5-D18B2BEC4478}"/>
               </a:ext>
             </a:extLst>
           </p:cNvPr>
@@ -11265,7 +11265,7 @@
           <p:cNvPr id="14" name="">
             <a:extLst xmlns:a="http://schemas.openxmlformats.org/drawingml/2006/main">
               <a:ext uri="{FF2B5EF4-FFF2-40B4-BE49-F238E27FC236}">
-                <a16:creationId xmlns:a16="http://schemas.microsoft.com/office/drawing/2014/main" id="{9169A51A-DB65-4A32-9555-5FB46738AA3B}"/>
+                <a16:creationId xmlns:a16="http://schemas.microsoft.com/office/drawing/2014/main" id="{50183E7C-8D57-4DC3-8EE3-C096A905B152}"/>
               </a:ext>
             </a:extLst>
           </p:cNvPr>
@@ -11320,7 +11320,7 @@
     </p:spTree>
     <p:extLst>
       <p:ext uri="{BB962C8B-B14F-4D97-AF65-F5344CB8AC3E}">
-        <p14:creationId xmlns:p14="http://schemas.microsoft.com/office/powerpoint/2010/main" val="885288023"/>
+        <p14:creationId xmlns:p14="http://schemas.microsoft.com/office/powerpoint/2010/main" val="996527836"/>
       </p:ext>
     </p:extLst>
   </p:cSld>
@@ -11351,7 +11351,7 @@
           <p:cNvPr id="13" name="">
             <a:extLst xmlns:a="http://schemas.openxmlformats.org/drawingml/2006/main">
               <a:ext uri="{FF2B5EF4-FFF2-40B4-BE49-F238E27FC236}">
-                <a16:creationId xmlns:a16="http://schemas.microsoft.com/office/drawing/2014/main" id="{06D8B22E-DA7B-4F1F-A6CA-A5B4F5DB34F8}"/>
+                <a16:creationId xmlns:a16="http://schemas.microsoft.com/office/drawing/2014/main" id="{15610237-06BC-4BD0-B7B7-1E5E94F715F7}"/>
               </a:ext>
             </a:extLst>
           </p:cNvPr>
@@ -11408,7 +11408,7 @@
           <p:cNvPr id="2" name="">
             <a:extLst xmlns:a="http://schemas.openxmlformats.org/drawingml/2006/main">
               <a:ext uri="{FF2B5EF4-FFF2-40B4-BE49-F238E27FC236}">
-                <a16:creationId xmlns:a16="http://schemas.microsoft.com/office/drawing/2014/main" id="{2F43EFD4-5A3D-41DE-A7D4-7DAD0615ADCC}"/>
+                <a16:creationId xmlns:a16="http://schemas.microsoft.com/office/drawing/2014/main" id="{872DFCAD-845E-4264-9589-8DFCFA126E38}"/>
               </a:ext>
             </a:extLst>
           </p:cNvPr>
@@ -11438,7 +11438,7 @@
           <p:cNvPr id="3" name="">
             <a:extLst xmlns:a="http://schemas.openxmlformats.org/drawingml/2006/main">
               <a:ext uri="{FF2B5EF4-FFF2-40B4-BE49-F238E27FC236}">
-                <a16:creationId xmlns:a16="http://schemas.microsoft.com/office/drawing/2014/main" id="{E1DC6982-03C3-4E24-9BF3-CF5828700BA0}"/>
+                <a16:creationId xmlns:a16="http://schemas.microsoft.com/office/drawing/2014/main" id="{529E0A34-11F2-4E6F-97A4-BD4F93BA1038}"/>
               </a:ext>
             </a:extLst>
           </p:cNvPr>
@@ -11502,7 +11502,7 @@
         </p:xfrm>
         <a:graphic xmlns:a="http://schemas.openxmlformats.org/drawingml/2006/main">
           <a:graphicData uri="http://schemas.openxmlformats.org/drawingml/2006/chart">
-            <c:chart xmlns:r="http://schemas.openxmlformats.org/officeDocument/2006/relationships" xmlns:c="http://schemas.openxmlformats.org/drawingml/2006/chart" r:id="R82d3b2b7c74d45f7"/>
+            <c:chart xmlns:r="http://schemas.openxmlformats.org/officeDocument/2006/relationships" xmlns:c="http://schemas.openxmlformats.org/drawingml/2006/chart" r:id="Rfdb760b013b848df"/>
           </a:graphicData>
         </a:graphic>
       </p:graphicFrame>
@@ -11511,7 +11511,7 @@
           <p:cNvPr id="5" name="">
             <a:extLst xmlns:a="http://schemas.openxmlformats.org/drawingml/2006/main">
               <a:ext uri="{FF2B5EF4-FFF2-40B4-BE49-F238E27FC236}">
-                <a16:creationId xmlns:a16="http://schemas.microsoft.com/office/drawing/2014/main" id="{89DABD61-F179-4BA4-88E7-FF4FD0902577}"/>
+                <a16:creationId xmlns:a16="http://schemas.microsoft.com/office/drawing/2014/main" id="{9EA3924B-611E-4B7E-84FB-6E26D740417F}"/>
               </a:ext>
             </a:extLst>
           </p:cNvPr>
@@ -11575,7 +11575,7 @@
         </p:xfrm>
         <a:graphic xmlns:a="http://schemas.openxmlformats.org/drawingml/2006/main">
           <a:graphicData uri="http://schemas.openxmlformats.org/drawingml/2006/chart">
-            <c:chart xmlns:r="http://schemas.openxmlformats.org/officeDocument/2006/relationships" xmlns:c="http://schemas.openxmlformats.org/drawingml/2006/chart" r:id="Rcd3e071e14074b20"/>
+            <c:chart xmlns:r="http://schemas.openxmlformats.org/officeDocument/2006/relationships" xmlns:c="http://schemas.openxmlformats.org/drawingml/2006/chart" r:id="R4027a014feaf442f"/>
           </a:graphicData>
         </a:graphic>
       </p:graphicFrame>
@@ -11584,7 +11584,7 @@
           <p:cNvPr id="7" name="">
             <a:extLst xmlns:a="http://schemas.openxmlformats.org/drawingml/2006/main">
               <a:ext uri="{FF2B5EF4-FFF2-40B4-BE49-F238E27FC236}">
-                <a16:creationId xmlns:a16="http://schemas.microsoft.com/office/drawing/2014/main" id="{C286C0A3-AEAF-4165-A32A-5D7769ECFCFE}"/>
+                <a16:creationId xmlns:a16="http://schemas.microsoft.com/office/drawing/2014/main" id="{7ED81D5D-9FBC-4089-BACD-F220B5D34EEB}"/>
               </a:ext>
             </a:extLst>
           </p:cNvPr>
@@ -11641,7 +11641,7 @@
           <p:cNvPr id="8" name="">
             <a:extLst xmlns:a="http://schemas.openxmlformats.org/drawingml/2006/main">
               <a:ext uri="{FF2B5EF4-FFF2-40B4-BE49-F238E27FC236}">
-                <a16:creationId xmlns:a16="http://schemas.microsoft.com/office/drawing/2014/main" id="{A42DAB60-7D8E-42DB-87A2-CC0B1C380A89}"/>
+                <a16:creationId xmlns:a16="http://schemas.microsoft.com/office/drawing/2014/main" id="{FC32E9E2-458E-46CB-B9EB-C56ED150A6EC}"/>
               </a:ext>
             </a:extLst>
           </p:cNvPr>
@@ -11700,7 +11700,7 @@
           <p:cNvPr id="9" name="">
             <a:extLst xmlns:a="http://schemas.openxmlformats.org/drawingml/2006/main">
               <a:ext uri="{FF2B5EF4-FFF2-40B4-BE49-F238E27FC236}">
-                <a16:creationId xmlns:a16="http://schemas.microsoft.com/office/drawing/2014/main" id="{B9C1A258-8B29-4F30-A453-ED5A36E3C027}"/>
+                <a16:creationId xmlns:a16="http://schemas.microsoft.com/office/drawing/2014/main" id="{51C19C16-8350-4E75-A118-609B456A5B89}"/>
               </a:ext>
             </a:extLst>
           </p:cNvPr>
@@ -11757,7 +11757,7 @@
           <p:cNvPr id="10" name="">
             <a:extLst xmlns:a="http://schemas.openxmlformats.org/drawingml/2006/main">
               <a:ext uri="{FF2B5EF4-FFF2-40B4-BE49-F238E27FC236}">
-                <a16:creationId xmlns:a16="http://schemas.microsoft.com/office/drawing/2014/main" id="{9AC68AD7-4C46-44DB-9013-5DD3CD58EC66}"/>
+                <a16:creationId xmlns:a16="http://schemas.microsoft.com/office/drawing/2014/main" id="{50F73025-3D33-4F26-9D46-F149DF145028}"/>
               </a:ext>
             </a:extLst>
           </p:cNvPr>
@@ -11787,7 +11787,7 @@
           <p:cNvPr id="11" name="">
             <a:extLst xmlns:a="http://schemas.openxmlformats.org/drawingml/2006/main">
               <a:ext uri="{FF2B5EF4-FFF2-40B4-BE49-F238E27FC236}">
-                <a16:creationId xmlns:a16="http://schemas.microsoft.com/office/drawing/2014/main" id="{8963AF5F-7474-498E-A7D2-F985E7740E26}"/>
+                <a16:creationId xmlns:a16="http://schemas.microsoft.com/office/drawing/2014/main" id="{E6770D5C-AB1A-4440-98DC-A0E752367E12}"/>
               </a:ext>
             </a:extLst>
           </p:cNvPr>
@@ -11844,7 +11844,7 @@
           <p:cNvPr id="12" name="">
             <a:extLst xmlns:a="http://schemas.openxmlformats.org/drawingml/2006/main">
               <a:ext uri="{FF2B5EF4-FFF2-40B4-BE49-F238E27FC236}">
-                <a16:creationId xmlns:a16="http://schemas.microsoft.com/office/drawing/2014/main" id="{2A93B065-0C62-4285-B0A6-73417B57BD66}"/>
+                <a16:creationId xmlns:a16="http://schemas.microsoft.com/office/drawing/2014/main" id="{532A48A6-6BDF-4DBF-9701-7707BFC85E0A}"/>
               </a:ext>
             </a:extLst>
           </p:cNvPr>
@@ -11899,7 +11899,7 @@
     </p:spTree>
     <p:extLst>
       <p:ext uri="{BB962C8B-B14F-4D97-AF65-F5344CB8AC3E}">
-        <p14:creationId xmlns:p14="http://schemas.microsoft.com/office/powerpoint/2010/main" val="722867460"/>
+        <p14:creationId xmlns:p14="http://schemas.microsoft.com/office/powerpoint/2010/main" val="1028877479"/>
       </p:ext>
     </p:extLst>
   </p:cSld>
@@ -11930,7 +11930,7 @@
           <p:cNvPr id="12" name="">
             <a:extLst xmlns:a="http://schemas.openxmlformats.org/drawingml/2006/main">
               <a:ext uri="{FF2B5EF4-FFF2-40B4-BE49-F238E27FC236}">
-                <a16:creationId xmlns:a16="http://schemas.microsoft.com/office/drawing/2014/main" id="{03F974FD-6970-41E4-9A43-80C9A027ECC8}"/>
+                <a16:creationId xmlns:a16="http://schemas.microsoft.com/office/drawing/2014/main" id="{B8BD82A0-03FE-4B49-81B1-9EF20863A4EA}"/>
               </a:ext>
             </a:extLst>
           </p:cNvPr>
@@ -11987,7 +11987,7 @@
           <p:cNvPr id="2" name="">
             <a:extLst xmlns:a="http://schemas.openxmlformats.org/drawingml/2006/main">
               <a:ext uri="{FF2B5EF4-FFF2-40B4-BE49-F238E27FC236}">
-                <a16:creationId xmlns:a16="http://schemas.microsoft.com/office/drawing/2014/main" id="{AB54498B-9725-48E8-A68E-7B61D01466AD}"/>
+                <a16:creationId xmlns:a16="http://schemas.microsoft.com/office/drawing/2014/main" id="{615D2A14-F191-46CE-8813-9BB2CE780985}"/>
               </a:ext>
             </a:extLst>
           </p:cNvPr>
@@ -12017,7 +12017,7 @@
           <p:cNvPr id="3" name="">
             <a:extLst xmlns:a="http://schemas.openxmlformats.org/drawingml/2006/main">
               <a:ext uri="{FF2B5EF4-FFF2-40B4-BE49-F238E27FC236}">
-                <a16:creationId xmlns:a16="http://schemas.microsoft.com/office/drawing/2014/main" id="{E3D838C9-91C1-4500-AC0C-2DF6A9A11879}"/>
+                <a16:creationId xmlns:a16="http://schemas.microsoft.com/office/drawing/2014/main" id="{CEC89F03-AA8B-43CE-B288-DA3CA67B8E55}"/>
               </a:ext>
             </a:extLst>
           </p:cNvPr>
@@ -12078,7 +12078,7 @@
           <p:nvPr/>
         </p:nvPicPr>
         <p:blipFill>
-          <a:blip xmlns:r="http://schemas.openxmlformats.org/officeDocument/2006/relationships" xmlns:a="http://schemas.openxmlformats.org/drawingml/2006/main" r:embed="Rcd83df72046242f7"/>
+          <a:blip xmlns:r="http://schemas.openxmlformats.org/officeDocument/2006/relationships" xmlns:a="http://schemas.openxmlformats.org/drawingml/2006/main" r:embed="R44212a8cd8064057"/>
           <a:stretch xmlns:a="http://schemas.openxmlformats.org/drawingml/2006/main"/>
         </p:blipFill>
         <p:spPr>
@@ -12100,7 +12100,7 @@
           <p:nvPr/>
         </p:nvPicPr>
         <p:blipFill>
-          <a:blip xmlns:r="http://schemas.openxmlformats.org/officeDocument/2006/relationships" xmlns:a="http://schemas.openxmlformats.org/drawingml/2006/main" r:embed="Rb0e3df3197bd4ab2"/>
+          <a:blip xmlns:r="http://schemas.openxmlformats.org/officeDocument/2006/relationships" xmlns:a="http://schemas.openxmlformats.org/drawingml/2006/main" r:embed="R61103316051b4b01"/>
           <a:stretch xmlns:a="http://schemas.openxmlformats.org/drawingml/2006/main"/>
         </p:blipFill>
         <p:spPr>
@@ -12118,7 +12118,7 @@
           <p:cNvPr id="6" name="">
             <a:extLst xmlns:a="http://schemas.openxmlformats.org/drawingml/2006/main">
               <a:ext uri="{FF2B5EF4-FFF2-40B4-BE49-F238E27FC236}">
-                <a16:creationId xmlns:a16="http://schemas.microsoft.com/office/drawing/2014/main" id="{D7CA1604-D7FF-4B9D-B3B6-0444C73D6974}"/>
+                <a16:creationId xmlns:a16="http://schemas.microsoft.com/office/drawing/2014/main" id="{3F391505-006F-41B9-BEFB-9EE72DCFD636}"/>
               </a:ext>
             </a:extLst>
           </p:cNvPr>
@@ -12175,7 +12175,7 @@
           <p:cNvPr id="7" name="">
             <a:extLst xmlns:a="http://schemas.openxmlformats.org/drawingml/2006/main">
               <a:ext uri="{FF2B5EF4-FFF2-40B4-BE49-F238E27FC236}">
-                <a16:creationId xmlns:a16="http://schemas.microsoft.com/office/drawing/2014/main" id="{6926719E-DEB2-4574-906F-6A2ECF1D6A78}"/>
+                <a16:creationId xmlns:a16="http://schemas.microsoft.com/office/drawing/2014/main" id="{D068C71F-97D7-4970-8922-1CFE0112F624}"/>
               </a:ext>
             </a:extLst>
           </p:cNvPr>
@@ -12255,7 +12255,7 @@
           <p:cNvPr id="8" name="">
             <a:extLst xmlns:a="http://schemas.openxmlformats.org/drawingml/2006/main">
               <a:ext uri="{FF2B5EF4-FFF2-40B4-BE49-F238E27FC236}">
-                <a16:creationId xmlns:a16="http://schemas.microsoft.com/office/drawing/2014/main" id="{751EE362-8C63-4E9B-A729-B99F716B4E5E}"/>
+                <a16:creationId xmlns:a16="http://schemas.microsoft.com/office/drawing/2014/main" id="{4E49AA08-B8FE-4695-BC68-8C9DEE1112AF}"/>
               </a:ext>
             </a:extLst>
           </p:cNvPr>
@@ -12337,7 +12337,7 @@
           <p:cNvPr id="9" name="">
             <a:extLst xmlns:a="http://schemas.openxmlformats.org/drawingml/2006/main">
               <a:ext uri="{FF2B5EF4-FFF2-40B4-BE49-F238E27FC236}">
-                <a16:creationId xmlns:a16="http://schemas.microsoft.com/office/drawing/2014/main" id="{4F5078C7-7136-4EF5-BB23-65A36A2B0FB8}"/>
+                <a16:creationId xmlns:a16="http://schemas.microsoft.com/office/drawing/2014/main" id="{CF9FA41F-DE8D-4EB2-8140-8ECE55C8C44B}"/>
               </a:ext>
             </a:extLst>
           </p:cNvPr>
@@ -12367,7 +12367,7 @@
           <p:cNvPr id="10" name="">
             <a:extLst xmlns:a="http://schemas.openxmlformats.org/drawingml/2006/main">
               <a:ext uri="{FF2B5EF4-FFF2-40B4-BE49-F238E27FC236}">
-                <a16:creationId xmlns:a16="http://schemas.microsoft.com/office/drawing/2014/main" id="{F8B729B2-85A2-416F-B1F9-17B021E98B50}"/>
+                <a16:creationId xmlns:a16="http://schemas.microsoft.com/office/drawing/2014/main" id="{80E3E06D-C459-4E33-B55A-C9C24F36BA3F}"/>
               </a:ext>
             </a:extLst>
           </p:cNvPr>
@@ -12424,7 +12424,7 @@
           <p:cNvPr id="11" name="">
             <a:extLst xmlns:a="http://schemas.openxmlformats.org/drawingml/2006/main">
               <a:ext uri="{FF2B5EF4-FFF2-40B4-BE49-F238E27FC236}">
-                <a16:creationId xmlns:a16="http://schemas.microsoft.com/office/drawing/2014/main" id="{59E2626E-8EA9-4C43-A5EC-527D07A24987}"/>
+                <a16:creationId xmlns:a16="http://schemas.microsoft.com/office/drawing/2014/main" id="{A6CAA586-2027-487F-9801-FE188B11C262}"/>
               </a:ext>
             </a:extLst>
           </p:cNvPr>
@@ -12479,7 +12479,7 @@
     </p:spTree>
     <p:extLst>
       <p:ext uri="{BB962C8B-B14F-4D97-AF65-F5344CB8AC3E}">
-        <p14:creationId xmlns:p14="http://schemas.microsoft.com/office/powerpoint/2010/main" val="1907720667"/>
+        <p14:creationId xmlns:p14="http://schemas.microsoft.com/office/powerpoint/2010/main" val="1224761245"/>
       </p:ext>
     </p:extLst>
   </p:cSld>
@@ -12510,7 +12510,7 @@
           <p:cNvPr id="11" name="">
             <a:extLst xmlns:a="http://schemas.openxmlformats.org/drawingml/2006/main">
               <a:ext uri="{FF2B5EF4-FFF2-40B4-BE49-F238E27FC236}">
-                <a16:creationId xmlns:a16="http://schemas.microsoft.com/office/drawing/2014/main" id="{A9A2FC44-AFD2-4B8E-95F0-DC36BC75A88F}"/>
+                <a16:creationId xmlns:a16="http://schemas.microsoft.com/office/drawing/2014/main" id="{AB753213-B045-4D49-95ED-8E5D8676F331}"/>
               </a:ext>
             </a:extLst>
           </p:cNvPr>
@@ -12567,7 +12567,7 @@
           <p:cNvPr id="2" name="">
             <a:extLst xmlns:a="http://schemas.openxmlformats.org/drawingml/2006/main">
               <a:ext uri="{FF2B5EF4-FFF2-40B4-BE49-F238E27FC236}">
-                <a16:creationId xmlns:a16="http://schemas.microsoft.com/office/drawing/2014/main" id="{12286ED5-D6F1-4BEA-8D3B-D2DD3B7B070D}"/>
+                <a16:creationId xmlns:a16="http://schemas.microsoft.com/office/drawing/2014/main" id="{8B82592F-076B-4FFF-898B-1A373167AD33}"/>
               </a:ext>
             </a:extLst>
           </p:cNvPr>
@@ -12597,7 +12597,7 @@
           <p:cNvPr id="3" name="">
             <a:extLst xmlns:a="http://schemas.openxmlformats.org/drawingml/2006/main">
               <a:ext uri="{FF2B5EF4-FFF2-40B4-BE49-F238E27FC236}">
-                <a16:creationId xmlns:a16="http://schemas.microsoft.com/office/drawing/2014/main" id="{F53B8C72-1ECE-480C-8929-85925F525BF6}"/>
+                <a16:creationId xmlns:a16="http://schemas.microsoft.com/office/drawing/2014/main" id="{F6C98C7F-34CE-4E50-97CA-B5EE9F86392D}"/>
               </a:ext>
             </a:extLst>
           </p:cNvPr>
@@ -13124,7 +13124,7 @@
           <p:nvPr/>
         </p:nvPicPr>
         <p:blipFill>
-          <a:blip xmlns:r="http://schemas.openxmlformats.org/officeDocument/2006/relationships" xmlns:a="http://schemas.openxmlformats.org/drawingml/2006/main" r:embed="R53ecb3ae60794d23"/>
+          <a:blip xmlns:r="http://schemas.openxmlformats.org/officeDocument/2006/relationships" xmlns:a="http://schemas.openxmlformats.org/drawingml/2006/main" r:embed="Rb5f217378a0c4432"/>
           <a:stretch xmlns:a="http://schemas.openxmlformats.org/drawingml/2006/main"/>
         </p:blipFill>
         <p:spPr>
@@ -13142,7 +13142,7 @@
           <p:cNvPr id="6" name="">
             <a:extLst xmlns:a="http://schemas.openxmlformats.org/drawingml/2006/main">
               <a:ext uri="{FF2B5EF4-FFF2-40B4-BE49-F238E27FC236}">
-                <a16:creationId xmlns:a16="http://schemas.microsoft.com/office/drawing/2014/main" id="{A5694468-81FA-4481-B6D4-7B28652DFA97}"/>
+                <a16:creationId xmlns:a16="http://schemas.microsoft.com/office/drawing/2014/main" id="{5CA66AF2-A647-4C6F-ADB2-4C702C87366C}"/>
               </a:ext>
             </a:extLst>
           </p:cNvPr>
@@ -13199,7 +13199,7 @@
           <p:cNvPr id="7" name="">
             <a:extLst xmlns:a="http://schemas.openxmlformats.org/drawingml/2006/main">
               <a:ext uri="{FF2B5EF4-FFF2-40B4-BE49-F238E27FC236}">
-                <a16:creationId xmlns:a16="http://schemas.microsoft.com/office/drawing/2014/main" id="{2DD1A097-F45B-4E9E-86F4-3100D536FB0F}"/>
+                <a16:creationId xmlns:a16="http://schemas.microsoft.com/office/drawing/2014/main" id="{7A664C04-BF86-4CFE-B3A0-A836A1001CFB}"/>
               </a:ext>
             </a:extLst>
           </p:cNvPr>
@@ -13304,7 +13304,7 @@
           <p:cNvPr id="8" name="">
             <a:extLst xmlns:a="http://schemas.openxmlformats.org/drawingml/2006/main">
               <a:ext uri="{FF2B5EF4-FFF2-40B4-BE49-F238E27FC236}">
-                <a16:creationId xmlns:a16="http://schemas.microsoft.com/office/drawing/2014/main" id="{1FD59376-4074-47A1-AD25-3615AC5AC31D}"/>
+                <a16:creationId xmlns:a16="http://schemas.microsoft.com/office/drawing/2014/main" id="{FE127044-5E70-402E-BF93-D02544224EF3}"/>
               </a:ext>
             </a:extLst>
           </p:cNvPr>
@@ -13334,7 +13334,7 @@
           <p:cNvPr id="9" name="">
             <a:extLst xmlns:a="http://schemas.openxmlformats.org/drawingml/2006/main">
               <a:ext uri="{FF2B5EF4-FFF2-40B4-BE49-F238E27FC236}">
-                <a16:creationId xmlns:a16="http://schemas.microsoft.com/office/drawing/2014/main" id="{4728B174-5E75-4529-8C2C-5D92B75C04F4}"/>
+                <a16:creationId xmlns:a16="http://schemas.microsoft.com/office/drawing/2014/main" id="{1A903496-D91F-41AE-B168-4BC65550B185}"/>
               </a:ext>
             </a:extLst>
           </p:cNvPr>
@@ -13391,7 +13391,7 @@
           <p:cNvPr id="10" name="">
             <a:extLst xmlns:a="http://schemas.openxmlformats.org/drawingml/2006/main">
               <a:ext uri="{FF2B5EF4-FFF2-40B4-BE49-F238E27FC236}">
-                <a16:creationId xmlns:a16="http://schemas.microsoft.com/office/drawing/2014/main" id="{EBDC7197-CF4E-4A0C-9752-CE85F3814E17}"/>
+                <a16:creationId xmlns:a16="http://schemas.microsoft.com/office/drawing/2014/main" id="{0E6132DE-814E-4792-A87F-D06F3BB73C37}"/>
               </a:ext>
             </a:extLst>
           </p:cNvPr>
@@ -13446,7 +13446,7 @@
     </p:spTree>
     <p:extLst>
       <p:ext uri="{BB962C8B-B14F-4D97-AF65-F5344CB8AC3E}">
-        <p14:creationId xmlns:p14="http://schemas.microsoft.com/office/powerpoint/2010/main" val="447658111"/>
+        <p14:creationId xmlns:p14="http://schemas.microsoft.com/office/powerpoint/2010/main" val="649028005"/>
       </p:ext>
     </p:extLst>
   </p:cSld>

</xml_diff>